<commit_message>
feat: custom fonts via docker bind mount + font refresh API
</commit_message>
<xml_diff>
--- a/app/templates/new.pptx
+++ b/app/templates/new.pptx
@@ -2,7 +2,7 @@
 <file path=ppt/presentation.xml><?xml version="1.0" encoding="utf-8"?>
 <p:presentation xmlns:a="http://schemas.openxmlformats.org/drawingml/2006/main" xmlns:r="http://schemas.openxmlformats.org/officeDocument/2006/relationships" xmlns:p="http://schemas.openxmlformats.org/presentationml/2006/main" saveSubsetFonts="1">
   <p:sldMasterIdLst>
-    <p:sldMasterId id="2147483648" r:id="rId1"/>
+    <p:sldMasterId id="2147483672" r:id="rId1"/>
   </p:sldMasterIdLst>
   <p:notesMasterIdLst>
     <p:notesMasterId r:id="rId3"/>
@@ -14,10 +14,10 @@
   <p:notesSz cx="6858000" cy="9144000"/>
   <p:defaultTextStyle>
     <a:defPPr>
-      <a:defRPr lang="zh-CN"/>
+      <a:defRPr lang="en-US"/>
     </a:defPPr>
-    <a:lvl1pPr marL="0" algn="l" defTabSz="914400" rtl="0">
-      <a:defRPr sz="1800">
+    <a:lvl1pPr marL="0" algn="l" defTabSz="914400" rtl="0" eaLnBrk="1" latinLnBrk="0" hangingPunct="1">
+      <a:defRPr sz="1800" kern="1200">
         <a:solidFill>
           <a:schemeClr val="tx1"/>
         </a:solidFill>
@@ -26,8 +26,8 @@
         <a:cs typeface="+mn-cs"/>
       </a:defRPr>
     </a:lvl1pPr>
-    <a:lvl2pPr marL="457200" algn="l" defTabSz="914400" rtl="0">
-      <a:defRPr sz="1800">
+    <a:lvl2pPr marL="457200" algn="l" defTabSz="914400" rtl="0" eaLnBrk="1" latinLnBrk="0" hangingPunct="1">
+      <a:defRPr sz="1800" kern="1200">
         <a:solidFill>
           <a:schemeClr val="tx1"/>
         </a:solidFill>
@@ -36,8 +36,8 @@
         <a:cs typeface="+mn-cs"/>
       </a:defRPr>
     </a:lvl2pPr>
-    <a:lvl3pPr marL="914400" algn="l" defTabSz="914400" rtl="0">
-      <a:defRPr sz="1800">
+    <a:lvl3pPr marL="914400" algn="l" defTabSz="914400" rtl="0" eaLnBrk="1" latinLnBrk="0" hangingPunct="1">
+      <a:defRPr sz="1800" kern="1200">
         <a:solidFill>
           <a:schemeClr val="tx1"/>
         </a:solidFill>
@@ -46,8 +46,8 @@
         <a:cs typeface="+mn-cs"/>
       </a:defRPr>
     </a:lvl3pPr>
-    <a:lvl4pPr marL="1371600" algn="l" defTabSz="914400" rtl="0">
-      <a:defRPr sz="1800">
+    <a:lvl4pPr marL="1371600" algn="l" defTabSz="914400" rtl="0" eaLnBrk="1" latinLnBrk="0" hangingPunct="1">
+      <a:defRPr sz="1800" kern="1200">
         <a:solidFill>
           <a:schemeClr val="tx1"/>
         </a:solidFill>
@@ -56,8 +56,8 @@
         <a:cs typeface="+mn-cs"/>
       </a:defRPr>
     </a:lvl4pPr>
-    <a:lvl5pPr marL="1828800" algn="l" defTabSz="914400" rtl="0">
-      <a:defRPr sz="1800">
+    <a:lvl5pPr marL="1828800" algn="l" defTabSz="914400" rtl="0" eaLnBrk="1" latinLnBrk="0" hangingPunct="1">
+      <a:defRPr sz="1800" kern="1200">
         <a:solidFill>
           <a:schemeClr val="tx1"/>
         </a:solidFill>
@@ -66,8 +66,8 @@
         <a:cs typeface="+mn-cs"/>
       </a:defRPr>
     </a:lvl5pPr>
-    <a:lvl6pPr marL="2286000" algn="l" defTabSz="914400" rtl="0">
-      <a:defRPr sz="1800">
+    <a:lvl6pPr marL="2286000" algn="l" defTabSz="914400" rtl="0" eaLnBrk="1" latinLnBrk="0" hangingPunct="1">
+      <a:defRPr sz="1800" kern="1200">
         <a:solidFill>
           <a:schemeClr val="tx1"/>
         </a:solidFill>
@@ -76,8 +76,8 @@
         <a:cs typeface="+mn-cs"/>
       </a:defRPr>
     </a:lvl6pPr>
-    <a:lvl7pPr marL="2743200" algn="l" defTabSz="914400" rtl="0">
-      <a:defRPr sz="1800">
+    <a:lvl7pPr marL="2743200" algn="l" defTabSz="914400" rtl="0" eaLnBrk="1" latinLnBrk="0" hangingPunct="1">
+      <a:defRPr sz="1800" kern="1200">
         <a:solidFill>
           <a:schemeClr val="tx1"/>
         </a:solidFill>
@@ -86,8 +86,8 @@
         <a:cs typeface="+mn-cs"/>
       </a:defRPr>
     </a:lvl7pPr>
-    <a:lvl8pPr marL="3200400" algn="l" defTabSz="914400" rtl="0">
-      <a:defRPr sz="1800">
+    <a:lvl8pPr marL="3200400" algn="l" defTabSz="914400" rtl="0" eaLnBrk="1" latinLnBrk="0" hangingPunct="1">
+      <a:defRPr sz="1800" kern="1200">
         <a:solidFill>
           <a:schemeClr val="tx1"/>
         </a:solidFill>
@@ -96,8 +96,8 @@
         <a:cs typeface="+mn-cs"/>
       </a:defRPr>
     </a:lvl8pPr>
-    <a:lvl9pPr marL="3657600" algn="l" defTabSz="914400" rtl="0">
-      <a:defRPr sz="1800">
+    <a:lvl9pPr marL="3657600" algn="l" defTabSz="914400" rtl="0" eaLnBrk="1" latinLnBrk="0" hangingPunct="1">
+      <a:defRPr sz="1800" kern="1200">
         <a:solidFill>
           <a:schemeClr val="tx1"/>
         </a:solidFill>
@@ -109,18 +109,10 @@
   </p:defaultTextStyle>
   <p:extLst>
     <p:ext uri="{EFAFB233-063F-42B5-8137-9DF3F51BA10A}">
-      <p15:sldGuideLst xmlns:p15="http://schemas.microsoft.com/office/powerpoint/2012/main">
-        <p15:guide id="1" pos="3840">
-          <p15:clr>
-            <a:srgbClr val="A4A3A4"/>
-          </p15:clr>
-        </p15:guide>
-        <p15:guide id="2" orient="horz" pos="2160">
-          <p15:clr>
-            <a:srgbClr val="A4A3A4"/>
-          </p15:clr>
-        </p15:guide>
-      </p15:sldGuideLst>
+      <p15:sldGuideLst xmlns:p15="http://schemas.microsoft.com/office/powerpoint/2012/main"/>
+    </p:ext>
+    <p:ext uri="{2D200454-40CA-4A62-9FC3-DE9A4176ACB9}">
+      <p15:notesGuideLst xmlns:p15="http://schemas.microsoft.com/office/powerpoint/2012/main"/>
     </p:ext>
   </p:extLst>
 </p:presentation>
@@ -140,7 +132,7 @@
         <p:cNvGrpSpPr/>
         <p:nvPr/>
       </p:nvGrpSpPr>
-      <p:grpSpPr bwMode="auto">
+      <p:grpSpPr>
         <a:xfrm>
           <a:off x="0" y="0"/>
           <a:ext cx="0" cy="0"/>
@@ -150,7 +142,7 @@
       </p:grpSpPr>
       <p:sp>
         <p:nvSpPr>
-          <p:cNvPr id="926586711" name="頁首預留位置 1"/>
+          <p:cNvPr id="2" name="Header Placeholder 1"/>
           <p:cNvSpPr>
             <a:spLocks noGrp="1"/>
           </p:cNvSpPr>
@@ -158,7 +150,7 @@
             <p:ph type="hdr" sz="quarter"/>
           </p:nvPr>
         </p:nvSpPr>
-        <p:spPr bwMode="auto">
+        <p:spPr>
           <a:xfrm>
             <a:off x="0" y="0"/>
             <a:ext cx="2971800" cy="458788"/>
@@ -175,16 +167,13 @@
             </a:lvl1pPr>
           </a:lstStyle>
           <a:p>
-            <a:pPr>
-              <a:defRPr/>
-            </a:pPr>
-            <a:endParaRPr lang="zh-CN"/>
-          </a:p>
-        </p:txBody>
-      </p:sp>
-      <p:sp>
-        <p:nvSpPr>
-          <p:cNvPr id="1990681168" name="日期預留位置 2"/>
+            <a:endParaRPr lang="en-US"/>
+          </a:p>
+        </p:txBody>
+      </p:sp>
+      <p:sp>
+        <p:nvSpPr>
+          <p:cNvPr id="3" name="Date Placeholder 2"/>
           <p:cNvSpPr>
             <a:spLocks noGrp="1"/>
           </p:cNvSpPr>
@@ -192,7 +181,7 @@
             <p:ph type="dt" idx="1"/>
           </p:nvPr>
         </p:nvSpPr>
-        <p:spPr bwMode="auto">
+        <p:spPr>
           <a:xfrm>
             <a:off x="3884613" y="0"/>
             <a:ext cx="2971800" cy="458788"/>
@@ -209,20 +198,17 @@
             </a:lvl1pPr>
           </a:lstStyle>
           <a:p>
-            <a:pPr>
-              <a:defRPr/>
-            </a:pPr>
             <a:fld id="{3632E96E-41F7-40C5-8419-297958CC00FA}" type="datetimeFigureOut">
-              <a:rPr lang="en-US" altLang="zh-CN"/>
-              <a:t>2026/4/10</a:t>
+              <a:rPr lang="en-US" smtClean="0"/>
+              <a:t>10/30/2013</a:t>
             </a:fld>
-            <a:endParaRPr lang="zh-CN"/>
-          </a:p>
-        </p:txBody>
-      </p:sp>
-      <p:sp>
-        <p:nvSpPr>
-          <p:cNvPr id="2066252378" name="投影片影像預留位置 3"/>
+            <a:endParaRPr lang="en-US"/>
+          </a:p>
+        </p:txBody>
+      </p:sp>
+      <p:sp>
+        <p:nvSpPr>
+          <p:cNvPr id="4" name="Slide Image Placeholder 3"/>
           <p:cNvSpPr>
             <a:spLocks noGrp="1" noRot="1" noChangeAspect="1"/>
           </p:cNvSpPr>
@@ -230,7 +216,7 @@
             <p:ph type="sldImg" idx="2"/>
           </p:nvPr>
         </p:nvSpPr>
-        <p:spPr bwMode="auto">
+        <p:spPr>
           <a:xfrm>
             <a:off x="685800" y="1143000"/>
             <a:ext cx="5486400" cy="3086100"/>
@@ -249,16 +235,13 @@
           <a:bodyPr vert="horz" lIns="91440" tIns="45720" rIns="91440" bIns="45720" rtlCol="0" anchor="ctr"/>
           <a:lstStyle/>
           <a:p>
-            <a:pPr>
-              <a:defRPr/>
-            </a:pPr>
-            <a:endParaRPr lang="zh-CN"/>
-          </a:p>
-        </p:txBody>
-      </p:sp>
-      <p:sp>
-        <p:nvSpPr>
-          <p:cNvPr id="798861881" name="備忘稿預留位置 4"/>
+            <a:endParaRPr lang="en-US"/>
+          </a:p>
+        </p:txBody>
+      </p:sp>
+      <p:sp>
+        <p:nvSpPr>
+          <p:cNvPr id="5" name="Notes Placeholder 4"/>
           <p:cNvSpPr>
             <a:spLocks noGrp="1"/>
           </p:cNvSpPr>
@@ -266,7 +249,7 @@
             <p:ph type="body" sz="quarter" idx="3"/>
           </p:nvPr>
         </p:nvSpPr>
-        <p:spPr bwMode="auto">
+        <p:spPr>
           <a:xfrm>
             <a:off x="685800" y="4400550"/>
             <a:ext cx="5486400" cy="3600450"/>
@@ -279,59 +262,46 @@
           <a:bodyPr vert="horz" lIns="91440" tIns="45720" rIns="91440" bIns="45720" rtlCol="0"/>
           <a:lstStyle/>
           <a:p>
-            <a:pPr lvl="0">
-              <a:defRPr/>
-            </a:pPr>
-            <a:r>
-              <a:rPr lang="zh-CN"/>
-              <a:t>单击此处编辑母版文本样式</a:t>
-            </a:r>
-            <a:endParaRPr/>
-          </a:p>
-          <a:p>
-            <a:pPr lvl="1">
-              <a:defRPr/>
-            </a:pPr>
-            <a:r>
-              <a:rPr lang="zh-CN"/>
-              <a:t>二级</a:t>
-            </a:r>
-            <a:endParaRPr/>
-          </a:p>
-          <a:p>
-            <a:pPr lvl="2">
-              <a:defRPr/>
-            </a:pPr>
-            <a:r>
-              <a:rPr lang="zh-CN"/>
-              <a:t>三级</a:t>
-            </a:r>
-            <a:endParaRPr/>
-          </a:p>
-          <a:p>
-            <a:pPr lvl="3">
-              <a:defRPr/>
-            </a:pPr>
-            <a:r>
-              <a:rPr lang="zh-CN"/>
-              <a:t>四级</a:t>
-            </a:r>
-            <a:endParaRPr/>
-          </a:p>
-          <a:p>
-            <a:pPr lvl="4">
-              <a:defRPr/>
-            </a:pPr>
-            <a:r>
-              <a:rPr lang="zh-CN"/>
-              <a:t>五级</a:t>
-            </a:r>
-          </a:p>
-        </p:txBody>
-      </p:sp>
-      <p:sp>
-        <p:nvSpPr>
-          <p:cNvPr id="1854493174" name="頁尾預留位置 5"/>
+            <a:pPr lvl="0"/>
+            <a:r>
+              <a:rPr lang="en-US" smtClean="0"/>
+              <a:t>Click to edit Master text styles</a:t>
+            </a:r>
+          </a:p>
+          <a:p>
+            <a:pPr lvl="1"/>
+            <a:r>
+              <a:rPr lang="en-US" smtClean="0"/>
+              <a:t>Second level</a:t>
+            </a:r>
+          </a:p>
+          <a:p>
+            <a:pPr lvl="2"/>
+            <a:r>
+              <a:rPr lang="en-US" smtClean="0"/>
+              <a:t>Third level</a:t>
+            </a:r>
+          </a:p>
+          <a:p>
+            <a:pPr lvl="3"/>
+            <a:r>
+              <a:rPr lang="en-US" smtClean="0"/>
+              <a:t>Fourth level</a:t>
+            </a:r>
+          </a:p>
+          <a:p>
+            <a:pPr lvl="4"/>
+            <a:r>
+              <a:rPr lang="en-US" smtClean="0"/>
+              <a:t>Fifth level</a:t>
+            </a:r>
+            <a:endParaRPr lang="en-US"/>
+          </a:p>
+        </p:txBody>
+      </p:sp>
+      <p:sp>
+        <p:nvSpPr>
+          <p:cNvPr id="6" name="Footer Placeholder 5"/>
           <p:cNvSpPr>
             <a:spLocks noGrp="1"/>
           </p:cNvSpPr>
@@ -339,7 +309,7 @@
             <p:ph type="ftr" sz="quarter" idx="4"/>
           </p:nvPr>
         </p:nvSpPr>
-        <p:spPr bwMode="auto">
+        <p:spPr>
           <a:xfrm>
             <a:off x="0" y="8685213"/>
             <a:ext cx="2971800" cy="458787"/>
@@ -356,16 +326,13 @@
             </a:lvl1pPr>
           </a:lstStyle>
           <a:p>
-            <a:pPr>
-              <a:defRPr/>
-            </a:pPr>
-            <a:endParaRPr lang="zh-CN"/>
-          </a:p>
-        </p:txBody>
-      </p:sp>
-      <p:sp>
-        <p:nvSpPr>
-          <p:cNvPr id="125502887" name="投影片編號預留位置 6"/>
+            <a:endParaRPr lang="en-US"/>
+          </a:p>
+        </p:txBody>
+      </p:sp>
+      <p:sp>
+        <p:nvSpPr>
+          <p:cNvPr id="7" name="Slide Number Placeholder 6"/>
           <p:cNvSpPr>
             <a:spLocks noGrp="1"/>
           </p:cNvSpPr>
@@ -373,7 +340,7 @@
             <p:ph type="sldNum" sz="quarter" idx="5"/>
           </p:nvPr>
         </p:nvSpPr>
-        <p:spPr bwMode="auto">
+        <p:spPr>
           <a:xfrm>
             <a:off x="3884613" y="8685213"/>
             <a:ext cx="2971800" cy="458787"/>
@@ -390,23 +357,25 @@
             </a:lvl1pPr>
           </a:lstStyle>
           <a:p>
-            <a:pPr>
-              <a:defRPr/>
-            </a:pPr>
             <a:fld id="{2E6999B8-B6B4-4561-A3CD-BBCDAB9FC9D9}" type="slidenum">
-              <a:rPr lang="zh-CN"/>
+              <a:rPr lang="en-US" smtClean="0"/>
               <a:t>‹#›</a:t>
             </a:fld>
-            <a:endParaRPr lang="zh-CN"/>
+            <a:endParaRPr lang="en-US"/>
           </a:p>
         </p:txBody>
       </p:sp>
     </p:spTree>
+    <p:extLst>
+      <p:ext uri="{BB962C8B-B14F-4D97-AF65-F5344CB8AC3E}">
+        <p14:creationId xmlns:p14="http://schemas.microsoft.com/office/powerpoint/2010/main" val="2743286597"/>
+      </p:ext>
+    </p:extLst>
   </p:cSld>
   <p:clrMap bg1="lt1" tx1="dk1" bg2="lt2" tx2="dk2" accent1="accent1" accent2="accent2" accent3="accent3" accent4="accent4" accent5="accent5" accent6="accent6" hlink="hlink" folHlink="folHlink"/>
   <p:notesStyle>
-    <a:lvl1pPr marL="0" algn="l" defTabSz="914400" rtl="0">
-      <a:defRPr sz="1200">
+    <a:lvl1pPr marL="0" algn="l" defTabSz="914400" rtl="0" eaLnBrk="1" latinLnBrk="0" hangingPunct="1">
+      <a:defRPr sz="1200" kern="1200">
         <a:solidFill>
           <a:schemeClr val="tx1"/>
         </a:solidFill>
@@ -415,8 +384,8 @@
         <a:cs typeface="+mn-cs"/>
       </a:defRPr>
     </a:lvl1pPr>
-    <a:lvl2pPr marL="457200" algn="l" defTabSz="914400" rtl="0">
-      <a:defRPr sz="1200">
+    <a:lvl2pPr marL="457200" algn="l" defTabSz="914400" rtl="0" eaLnBrk="1" latinLnBrk="0" hangingPunct="1">
+      <a:defRPr sz="1200" kern="1200">
         <a:solidFill>
           <a:schemeClr val="tx1"/>
         </a:solidFill>
@@ -425,8 +394,8 @@
         <a:cs typeface="+mn-cs"/>
       </a:defRPr>
     </a:lvl2pPr>
-    <a:lvl3pPr marL="914400" algn="l" defTabSz="914400" rtl="0">
-      <a:defRPr sz="1200">
+    <a:lvl3pPr marL="914400" algn="l" defTabSz="914400" rtl="0" eaLnBrk="1" latinLnBrk="0" hangingPunct="1">
+      <a:defRPr sz="1200" kern="1200">
         <a:solidFill>
           <a:schemeClr val="tx1"/>
         </a:solidFill>
@@ -435,8 +404,8 @@
         <a:cs typeface="+mn-cs"/>
       </a:defRPr>
     </a:lvl3pPr>
-    <a:lvl4pPr marL="1371600" algn="l" defTabSz="914400" rtl="0">
-      <a:defRPr sz="1200">
+    <a:lvl4pPr marL="1371600" algn="l" defTabSz="914400" rtl="0" eaLnBrk="1" latinLnBrk="0" hangingPunct="1">
+      <a:defRPr sz="1200" kern="1200">
         <a:solidFill>
           <a:schemeClr val="tx1"/>
         </a:solidFill>
@@ -445,8 +414,8 @@
         <a:cs typeface="+mn-cs"/>
       </a:defRPr>
     </a:lvl4pPr>
-    <a:lvl5pPr marL="1828800" algn="l" defTabSz="914400" rtl="0">
-      <a:defRPr sz="1200">
+    <a:lvl5pPr marL="1828800" algn="l" defTabSz="914400" rtl="0" eaLnBrk="1" latinLnBrk="0" hangingPunct="1">
+      <a:defRPr sz="1200" kern="1200">
         <a:solidFill>
           <a:schemeClr val="tx1"/>
         </a:solidFill>
@@ -455,8 +424,8 @@
         <a:cs typeface="+mn-cs"/>
       </a:defRPr>
     </a:lvl5pPr>
-    <a:lvl6pPr marL="2286000" algn="l" defTabSz="914400" rtl="0">
-      <a:defRPr sz="1200">
+    <a:lvl6pPr marL="2286000" algn="l" defTabSz="914400" rtl="0" eaLnBrk="1" latinLnBrk="0" hangingPunct="1">
+      <a:defRPr sz="1200" kern="1200">
         <a:solidFill>
           <a:schemeClr val="tx1"/>
         </a:solidFill>
@@ -465,8 +434,8 @@
         <a:cs typeface="+mn-cs"/>
       </a:defRPr>
     </a:lvl6pPr>
-    <a:lvl7pPr marL="2743200" algn="l" defTabSz="914400" rtl="0">
-      <a:defRPr sz="1200">
+    <a:lvl7pPr marL="2743200" algn="l" defTabSz="914400" rtl="0" eaLnBrk="1" latinLnBrk="0" hangingPunct="1">
+      <a:defRPr sz="1200" kern="1200">
         <a:solidFill>
           <a:schemeClr val="tx1"/>
         </a:solidFill>
@@ -475,8 +444,8 @@
         <a:cs typeface="+mn-cs"/>
       </a:defRPr>
     </a:lvl7pPr>
-    <a:lvl8pPr marL="3200400" algn="l" defTabSz="914400" rtl="0">
-      <a:defRPr sz="1200">
+    <a:lvl8pPr marL="3200400" algn="l" defTabSz="914400" rtl="0" eaLnBrk="1" latinLnBrk="0" hangingPunct="1">
+      <a:defRPr sz="1200" kern="1200">
         <a:solidFill>
           <a:schemeClr val="tx1"/>
         </a:solidFill>
@@ -485,8 +454,8 @@
         <a:cs typeface="+mn-cs"/>
       </a:defRPr>
     </a:lvl8pPr>
-    <a:lvl9pPr marL="3657600" algn="l" defTabSz="914400" rtl="0">
-      <a:defRPr sz="1200">
+    <a:lvl9pPr marL="3657600" algn="l" defTabSz="914400" rtl="0" eaLnBrk="1" latinLnBrk="0" hangingPunct="1">
+      <a:defRPr sz="1200" kern="1200">
         <a:solidFill>
           <a:schemeClr val="tx1"/>
         </a:solidFill>
@@ -508,7 +477,7 @@
         <p:cNvGrpSpPr/>
         <p:nvPr/>
       </p:nvGrpSpPr>
-      <p:grpSpPr bwMode="auto">
+      <p:grpSpPr>
         <a:xfrm>
           <a:off x="0" y="0"/>
           <a:ext cx="0" cy="0"/>
@@ -518,7 +487,7 @@
       </p:grpSpPr>
       <p:sp>
         <p:nvSpPr>
-          <p:cNvPr id="691496501" name="投影片影像預留位置 1"/>
+          <p:cNvPr id="2" name="Slide Image Placeholder 1"/>
           <p:cNvSpPr>
             <a:spLocks noGrp="1" noRot="1" noChangeAspect="1"/>
           </p:cNvSpPr>
@@ -526,7 +495,7 @@
             <p:ph type="sldImg"/>
           </p:nvPr>
         </p:nvSpPr>
-        <p:spPr bwMode="auto">
+        <p:spPr>
           <a:xfrm>
             <a:off x="685800" y="1143000"/>
             <a:ext cx="5486400" cy="3086100"/>
@@ -535,7 +504,7 @@
       </p:sp>
       <p:sp>
         <p:nvSpPr>
-          <p:cNvPr id="1862948544" name="備忘稿預留位置 2"/>
+          <p:cNvPr id="3" name="Notes Placeholder 2"/>
           <p:cNvSpPr>
             <a:spLocks noGrp="1"/>
           </p:cNvSpPr>
@@ -543,24 +512,21 @@
             <p:ph type="body" idx="1"/>
           </p:nvPr>
         </p:nvSpPr>
-        <p:spPr bwMode="auto"/>
-        <p:txBody>
-          <a:bodyPr/>
-          <a:lstStyle/>
-          <a:p>
-            <a:pPr>
-              <a:defRPr/>
-            </a:pPr>
-            <a:endParaRPr lang="zh-CN">
-              <a:latin typeface="Arial"/>
-              <a:cs typeface="Arial"/>
+        <p:spPr/>
+        <p:txBody>
+          <a:bodyPr/>
+          <a:lstStyle/>
+          <a:p>
+            <a:endParaRPr lang="en-US" dirty="0">
+              <a:latin typeface="Arial" panose="020B0604020202020204" pitchFamily="34" charset="0"/>
+              <a:cs typeface="Arial" panose="020B0604020202020204" pitchFamily="34" charset="0"/>
             </a:endParaRPr>
           </a:p>
         </p:txBody>
       </p:sp>
       <p:sp>
         <p:nvSpPr>
-          <p:cNvPr id="1565800824" name="投影片編號預留位置 3"/>
+          <p:cNvPr id="4" name="Slide Number Placeholder 3"/>
           <p:cNvSpPr>
             <a:spLocks noGrp="1"/>
           </p:cNvSpPr>
@@ -568,23 +534,25 @@
             <p:ph type="sldNum" sz="quarter" idx="10"/>
           </p:nvPr>
         </p:nvSpPr>
-        <p:spPr bwMode="auto"/>
-        <p:txBody>
-          <a:bodyPr/>
-          <a:lstStyle/>
-          <a:p>
-            <a:pPr>
-              <a:defRPr/>
-            </a:pPr>
+        <p:spPr/>
+        <p:txBody>
+          <a:bodyPr/>
+          <a:lstStyle/>
+          <a:p>
             <a:fld id="{2E6999B8-B6B4-4561-A3CD-BBCDAB9FC9D9}" type="slidenum">
-              <a:rPr lang="zh-CN"/>
+              <a:rPr lang="en-US" smtClean="0"/>
               <a:t>1</a:t>
             </a:fld>
-            <a:endParaRPr lang="zh-CN"/>
+            <a:endParaRPr lang="en-US"/>
           </a:p>
         </p:txBody>
       </p:sp>
     </p:spTree>
+    <p:extLst>
+      <p:ext uri="{BB962C8B-B14F-4D97-AF65-F5344CB8AC3E}">
+        <p14:creationId xmlns:p14="http://schemas.microsoft.com/office/powerpoint/2010/main" val="867644256"/>
+      </p:ext>
+    </p:extLst>
   </p:cSld>
   <p:clrMapOvr>
     <a:masterClrMapping/>
@@ -593,15 +561,15 @@
 </file>
 
 <file path=ppt/slideLayouts/slideLayout1.xml><?xml version="1.0" encoding="utf-8"?>
-<p:sldLayout xmlns:a="http://schemas.openxmlformats.org/drawingml/2006/main" xmlns:r="http://schemas.openxmlformats.org/officeDocument/2006/relationships" xmlns:p="http://schemas.openxmlformats.org/presentationml/2006/main" showMasterPhAnim="0" type="title" preserve="1" userDrawn="1">
-  <p:cSld name="标题幻灯片">
+<p:sldLayout xmlns:a="http://schemas.openxmlformats.org/drawingml/2006/main" xmlns:r="http://schemas.openxmlformats.org/officeDocument/2006/relationships" xmlns:p="http://schemas.openxmlformats.org/presentationml/2006/main" type="title" preserve="1">
+  <p:cSld name="Title Slide">
     <p:spTree>
       <p:nvGrpSpPr>
         <p:cNvPr id="1" name=""/>
         <p:cNvGrpSpPr/>
         <p:nvPr/>
       </p:nvGrpSpPr>
-      <p:grpSpPr bwMode="auto">
+      <p:grpSpPr>
         <a:xfrm>
           <a:off x="0" y="0"/>
           <a:ext cx="0" cy="0"/>
@@ -611,7 +579,7 @@
       </p:grpSpPr>
       <p:sp>
         <p:nvSpPr>
-          <p:cNvPr id="1401406964" name="标题 1"/>
+          <p:cNvPr id="2" name="Title 1"/>
           <p:cNvSpPr>
             <a:spLocks noGrp="1"/>
           </p:cNvSpPr>
@@ -619,7 +587,7 @@
             <p:ph type="ctrTitle"/>
           </p:nvPr>
         </p:nvSpPr>
-        <p:spPr bwMode="auto">
+        <p:spPr>
           <a:xfrm>
             <a:off x="1524000" y="1122363"/>
             <a:ext cx="9144000" cy="2387600"/>
@@ -633,19 +601,17 @@
             </a:lvl1pPr>
           </a:lstStyle>
           <a:p>
-            <a:pPr>
-              <a:defRPr/>
-            </a:pPr>
-            <a:r>
-              <a:rPr lang="zh-CN"/>
-              <a:t>单击此处编辑母版标题样式</a:t>
-            </a:r>
-          </a:p>
-        </p:txBody>
-      </p:sp>
-      <p:sp>
-        <p:nvSpPr>
-          <p:cNvPr id="463146695" name="副标题 2"/>
+            <a:r>
+              <a:rPr lang="en-US" smtClean="0"/>
+              <a:t>Click to edit Master title style</a:t>
+            </a:r>
+            <a:endParaRPr lang="en-US" dirty="0"/>
+          </a:p>
+        </p:txBody>
+      </p:sp>
+      <p:sp>
+        <p:nvSpPr>
+          <p:cNvPr id="3" name="Subtitle 2"/>
           <p:cNvSpPr>
             <a:spLocks noGrp="1"/>
           </p:cNvSpPr>
@@ -653,7 +619,7 @@
             <p:ph type="subTitle" idx="1"/>
           </p:nvPr>
         </p:nvSpPr>
-        <p:spPr bwMode="auto">
+        <p:spPr>
           <a:xfrm>
             <a:off x="1524000" y="3602038"/>
             <a:ext cx="9144000" cy="1655762"/>
@@ -700,19 +666,17 @@
             </a:lvl9pPr>
           </a:lstStyle>
           <a:p>
-            <a:pPr>
-              <a:defRPr/>
-            </a:pPr>
-            <a:r>
-              <a:rPr lang="zh-CN"/>
-              <a:t>单击此处编辑母版副标题样式</a:t>
-            </a:r>
-          </a:p>
-        </p:txBody>
-      </p:sp>
-      <p:sp>
-        <p:nvSpPr>
-          <p:cNvPr id="254356156" name="日期占位符 3"/>
+            <a:r>
+              <a:rPr lang="en-US" smtClean="0"/>
+              <a:t>Click to edit Master subtitle style</a:t>
+            </a:r>
+            <a:endParaRPr lang="en-US" dirty="0"/>
+          </a:p>
+        </p:txBody>
+      </p:sp>
+      <p:sp>
+        <p:nvSpPr>
+          <p:cNvPr id="4" name="Date Placeholder 3"/>
           <p:cNvSpPr>
             <a:spLocks noGrp="1"/>
           </p:cNvSpPr>
@@ -720,25 +684,22 @@
             <p:ph type="dt" sz="half" idx="10"/>
           </p:nvPr>
         </p:nvSpPr>
-        <p:spPr bwMode="auto"/>
-        <p:txBody>
-          <a:bodyPr/>
-          <a:lstStyle/>
-          <a:p>
-            <a:pPr>
-              <a:defRPr/>
-            </a:pPr>
+        <p:spPr/>
+        <p:txBody>
+          <a:bodyPr/>
+          <a:lstStyle/>
+          <a:p>
             <a:fld id="{BCC18F51-09EC-435C-A3BA-64A766E099C0}" type="datetimeFigureOut">
-              <a:rPr lang="en-US" altLang="zh-CN"/>
-              <a:t>2026/4/10</a:t>
+              <a:rPr lang="en-US" smtClean="0"/>
+              <a:t>30.10.2013</a:t>
             </a:fld>
-            <a:endParaRPr lang="zh-CN"/>
-          </a:p>
-        </p:txBody>
-      </p:sp>
-      <p:sp>
-        <p:nvSpPr>
-          <p:cNvPr id="114962164" name="页脚占位符 4"/>
+            <a:endParaRPr lang="en-US"/>
+          </a:p>
+        </p:txBody>
+      </p:sp>
+      <p:sp>
+        <p:nvSpPr>
+          <p:cNvPr id="5" name="Footer Placeholder 4"/>
           <p:cNvSpPr>
             <a:spLocks noGrp="1"/>
           </p:cNvSpPr>
@@ -746,21 +707,18 @@
             <p:ph type="ftr" sz="quarter" idx="11"/>
           </p:nvPr>
         </p:nvSpPr>
-        <p:spPr bwMode="auto"/>
-        <p:txBody>
-          <a:bodyPr/>
-          <a:lstStyle/>
-          <a:p>
-            <a:pPr>
-              <a:defRPr/>
-            </a:pPr>
-            <a:endParaRPr lang="zh-CN"/>
-          </a:p>
-        </p:txBody>
-      </p:sp>
-      <p:sp>
-        <p:nvSpPr>
-          <p:cNvPr id="713013020" name="灯片编号占位符 5"/>
+        <p:spPr/>
+        <p:txBody>
+          <a:bodyPr/>
+          <a:lstStyle/>
+          <a:p>
+            <a:endParaRPr lang="en-US"/>
+          </a:p>
+        </p:txBody>
+      </p:sp>
+      <p:sp>
+        <p:nvSpPr>
+          <p:cNvPr id="6" name="Slide Number Placeholder 5"/>
           <p:cNvSpPr>
             <a:spLocks noGrp="1"/>
           </p:cNvSpPr>
@@ -768,23 +726,25 @@
             <p:ph type="sldNum" sz="quarter" idx="12"/>
           </p:nvPr>
         </p:nvSpPr>
-        <p:spPr bwMode="auto"/>
-        <p:txBody>
-          <a:bodyPr/>
-          <a:lstStyle/>
-          <a:p>
-            <a:pPr>
-              <a:defRPr/>
-            </a:pPr>
+        <p:spPr/>
+        <p:txBody>
+          <a:bodyPr/>
+          <a:lstStyle/>
+          <a:p>
             <a:fld id="{08395586-F03A-48D1-94DF-16B239DF4FB5}" type="slidenum">
-              <a:rPr lang="zh-CN"/>
+              <a:rPr lang="en-US" smtClean="0"/>
               <a:t>‹#›</a:t>
             </a:fld>
-            <a:endParaRPr lang="zh-CN"/>
+            <a:endParaRPr lang="en-US"/>
           </a:p>
         </p:txBody>
       </p:sp>
     </p:spTree>
+    <p:extLst>
+      <p:ext uri="{BB962C8B-B14F-4D97-AF65-F5344CB8AC3E}">
+        <p14:creationId xmlns:p14="http://schemas.microsoft.com/office/powerpoint/2010/main" val="2520518546"/>
+      </p:ext>
+    </p:extLst>
   </p:cSld>
   <p:clrMapOvr>
     <a:masterClrMapping/>
@@ -793,15 +753,15 @@
 </file>
 
 <file path=ppt/slideLayouts/slideLayout10.xml><?xml version="1.0" encoding="utf-8"?>
-<p:sldLayout xmlns:a="http://schemas.openxmlformats.org/drawingml/2006/main" xmlns:r="http://schemas.openxmlformats.org/officeDocument/2006/relationships" xmlns:p="http://schemas.openxmlformats.org/presentationml/2006/main" showMasterPhAnim="0" type="vertTx" preserve="1" userDrawn="1">
-  <p:cSld name="标题和竖排文字">
+<p:sldLayout xmlns:a="http://schemas.openxmlformats.org/drawingml/2006/main" xmlns:r="http://schemas.openxmlformats.org/officeDocument/2006/relationships" xmlns:p="http://schemas.openxmlformats.org/presentationml/2006/main" type="vertTx" preserve="1">
+  <p:cSld name="Title and Vertical Text">
     <p:spTree>
       <p:nvGrpSpPr>
         <p:cNvPr id="1" name=""/>
         <p:cNvGrpSpPr/>
         <p:nvPr/>
       </p:nvGrpSpPr>
-      <p:grpSpPr bwMode="auto">
+      <p:grpSpPr>
         <a:xfrm>
           <a:off x="0" y="0"/>
           <a:ext cx="0" cy="0"/>
@@ -811,7 +771,7 @@
       </p:grpSpPr>
       <p:sp>
         <p:nvSpPr>
-          <p:cNvPr id="234246294" name="标题 1"/>
+          <p:cNvPr id="2" name="Title 1"/>
           <p:cNvSpPr>
             <a:spLocks noGrp="1"/>
           </p:cNvSpPr>
@@ -819,24 +779,22 @@
             <p:ph type="title"/>
           </p:nvPr>
         </p:nvSpPr>
-        <p:spPr bwMode="auto"/>
-        <p:txBody>
-          <a:bodyPr/>
-          <a:lstStyle/>
-          <a:p>
-            <a:pPr>
-              <a:defRPr/>
-            </a:pPr>
-            <a:r>
-              <a:rPr lang="zh-CN"/>
-              <a:t>单击此处编辑母版标题样式</a:t>
-            </a:r>
-          </a:p>
-        </p:txBody>
-      </p:sp>
-      <p:sp>
-        <p:nvSpPr>
-          <p:cNvPr id="567508664" name="竖排文字占位符 2"/>
+        <p:spPr/>
+        <p:txBody>
+          <a:bodyPr/>
+          <a:lstStyle/>
+          <a:p>
+            <a:r>
+              <a:rPr lang="en-US" smtClean="0"/>
+              <a:t>Click to edit Master title style</a:t>
+            </a:r>
+            <a:endParaRPr lang="en-US" dirty="0"/>
+          </a:p>
+        </p:txBody>
+      </p:sp>
+      <p:sp>
+        <p:nvSpPr>
+          <p:cNvPr id="3" name="Vertical Text Placeholder 2"/>
           <p:cNvSpPr>
             <a:spLocks noGrp="1"/>
           </p:cNvSpPr>
@@ -844,64 +802,51 @@
             <p:ph type="body" orient="vert" idx="1"/>
           </p:nvPr>
         </p:nvSpPr>
-        <p:spPr bwMode="auto"/>
+        <p:spPr/>
         <p:txBody>
           <a:bodyPr vert="eaVert"/>
           <a:lstStyle/>
           <a:p>
-            <a:pPr lvl="0">
-              <a:defRPr/>
-            </a:pPr>
-            <a:r>
-              <a:rPr lang="zh-CN"/>
-              <a:t>单击此处编辑母版文本样式</a:t>
-            </a:r>
-            <a:endParaRPr/>
-          </a:p>
-          <a:p>
-            <a:pPr lvl="1">
-              <a:defRPr/>
-            </a:pPr>
-            <a:r>
-              <a:rPr lang="zh-CN"/>
-              <a:t>二级</a:t>
-            </a:r>
-            <a:endParaRPr/>
-          </a:p>
-          <a:p>
-            <a:pPr lvl="2">
-              <a:defRPr/>
-            </a:pPr>
-            <a:r>
-              <a:rPr lang="zh-CN"/>
-              <a:t>三级</a:t>
-            </a:r>
-            <a:endParaRPr/>
-          </a:p>
-          <a:p>
-            <a:pPr lvl="3">
-              <a:defRPr/>
-            </a:pPr>
-            <a:r>
-              <a:rPr lang="zh-CN"/>
-              <a:t>四级</a:t>
-            </a:r>
-            <a:endParaRPr/>
-          </a:p>
-          <a:p>
-            <a:pPr lvl="4">
-              <a:defRPr/>
-            </a:pPr>
-            <a:r>
-              <a:rPr lang="zh-CN"/>
-              <a:t>五级</a:t>
-            </a:r>
-          </a:p>
-        </p:txBody>
-      </p:sp>
-      <p:sp>
-        <p:nvSpPr>
-          <p:cNvPr id="60458396" name="日期占位符 3"/>
+            <a:pPr lvl="0"/>
+            <a:r>
+              <a:rPr lang="en-US" smtClean="0"/>
+              <a:t>Click to edit Master text styles</a:t>
+            </a:r>
+          </a:p>
+          <a:p>
+            <a:pPr lvl="1"/>
+            <a:r>
+              <a:rPr lang="en-US" smtClean="0"/>
+              <a:t>Second level</a:t>
+            </a:r>
+          </a:p>
+          <a:p>
+            <a:pPr lvl="2"/>
+            <a:r>
+              <a:rPr lang="en-US" smtClean="0"/>
+              <a:t>Third level</a:t>
+            </a:r>
+          </a:p>
+          <a:p>
+            <a:pPr lvl="3"/>
+            <a:r>
+              <a:rPr lang="en-US" smtClean="0"/>
+              <a:t>Fourth level</a:t>
+            </a:r>
+          </a:p>
+          <a:p>
+            <a:pPr lvl="4"/>
+            <a:r>
+              <a:rPr lang="en-US" smtClean="0"/>
+              <a:t>Fifth level</a:t>
+            </a:r>
+            <a:endParaRPr lang="en-US" dirty="0"/>
+          </a:p>
+        </p:txBody>
+      </p:sp>
+      <p:sp>
+        <p:nvSpPr>
+          <p:cNvPr id="4" name="Date Placeholder 3"/>
           <p:cNvSpPr>
             <a:spLocks noGrp="1"/>
           </p:cNvSpPr>
@@ -909,25 +854,22 @@
             <p:ph type="dt" sz="half" idx="10"/>
           </p:nvPr>
         </p:nvSpPr>
-        <p:spPr bwMode="auto"/>
-        <p:txBody>
-          <a:bodyPr/>
-          <a:lstStyle/>
-          <a:p>
-            <a:pPr>
-              <a:defRPr/>
-            </a:pPr>
+        <p:spPr/>
+        <p:txBody>
+          <a:bodyPr/>
+          <a:lstStyle/>
+          <a:p>
             <a:fld id="{BCC18F51-09EC-435C-A3BA-64A766E099C0}" type="datetimeFigureOut">
-              <a:rPr lang="en-US" altLang="zh-CN"/>
-              <a:t>2026/4/10</a:t>
+              <a:rPr lang="en-US" smtClean="0"/>
+              <a:t>30.10.2013</a:t>
             </a:fld>
-            <a:endParaRPr lang="zh-CN"/>
-          </a:p>
-        </p:txBody>
-      </p:sp>
-      <p:sp>
-        <p:nvSpPr>
-          <p:cNvPr id="146550233" name="页脚占位符 4"/>
+            <a:endParaRPr lang="en-US"/>
+          </a:p>
+        </p:txBody>
+      </p:sp>
+      <p:sp>
+        <p:nvSpPr>
+          <p:cNvPr id="5" name="Footer Placeholder 4"/>
           <p:cNvSpPr>
             <a:spLocks noGrp="1"/>
           </p:cNvSpPr>
@@ -935,21 +877,18 @@
             <p:ph type="ftr" sz="quarter" idx="11"/>
           </p:nvPr>
         </p:nvSpPr>
-        <p:spPr bwMode="auto"/>
-        <p:txBody>
-          <a:bodyPr/>
-          <a:lstStyle/>
-          <a:p>
-            <a:pPr>
-              <a:defRPr/>
-            </a:pPr>
-            <a:endParaRPr lang="zh-CN"/>
-          </a:p>
-        </p:txBody>
-      </p:sp>
-      <p:sp>
-        <p:nvSpPr>
-          <p:cNvPr id="1569123788" name="灯片编号占位符 5"/>
+        <p:spPr/>
+        <p:txBody>
+          <a:bodyPr/>
+          <a:lstStyle/>
+          <a:p>
+            <a:endParaRPr lang="en-US"/>
+          </a:p>
+        </p:txBody>
+      </p:sp>
+      <p:sp>
+        <p:nvSpPr>
+          <p:cNvPr id="6" name="Slide Number Placeholder 5"/>
           <p:cNvSpPr>
             <a:spLocks noGrp="1"/>
           </p:cNvSpPr>
@@ -957,23 +896,25 @@
             <p:ph type="sldNum" sz="quarter" idx="12"/>
           </p:nvPr>
         </p:nvSpPr>
-        <p:spPr bwMode="auto"/>
-        <p:txBody>
-          <a:bodyPr/>
-          <a:lstStyle/>
-          <a:p>
-            <a:pPr>
-              <a:defRPr/>
-            </a:pPr>
+        <p:spPr/>
+        <p:txBody>
+          <a:bodyPr/>
+          <a:lstStyle/>
+          <a:p>
             <a:fld id="{08395586-F03A-48D1-94DF-16B239DF4FB5}" type="slidenum">
-              <a:rPr lang="zh-CN"/>
+              <a:rPr lang="en-US" smtClean="0"/>
               <a:t>‹#›</a:t>
             </a:fld>
-            <a:endParaRPr lang="zh-CN"/>
+            <a:endParaRPr lang="en-US"/>
           </a:p>
         </p:txBody>
       </p:sp>
     </p:spTree>
+    <p:extLst>
+      <p:ext uri="{BB962C8B-B14F-4D97-AF65-F5344CB8AC3E}">
+        <p14:creationId xmlns:p14="http://schemas.microsoft.com/office/powerpoint/2010/main" val="2377304659"/>
+      </p:ext>
+    </p:extLst>
   </p:cSld>
   <p:clrMapOvr>
     <a:masterClrMapping/>
@@ -982,15 +923,15 @@
 </file>
 
 <file path=ppt/slideLayouts/slideLayout11.xml><?xml version="1.0" encoding="utf-8"?>
-<p:sldLayout xmlns:a="http://schemas.openxmlformats.org/drawingml/2006/main" xmlns:r="http://schemas.openxmlformats.org/officeDocument/2006/relationships" xmlns:p="http://schemas.openxmlformats.org/presentationml/2006/main" showMasterPhAnim="0" type="vertTitleAndTx" preserve="1" userDrawn="1">
-  <p:cSld name="竖排标题与文本">
+<p:sldLayout xmlns:a="http://schemas.openxmlformats.org/drawingml/2006/main" xmlns:r="http://schemas.openxmlformats.org/officeDocument/2006/relationships" xmlns:p="http://schemas.openxmlformats.org/presentationml/2006/main" type="vertTitleAndTx" preserve="1">
+  <p:cSld name="Vertical Title and Text">
     <p:spTree>
       <p:nvGrpSpPr>
         <p:cNvPr id="1" name=""/>
         <p:cNvGrpSpPr/>
         <p:nvPr/>
       </p:nvGrpSpPr>
-      <p:grpSpPr bwMode="auto">
+      <p:grpSpPr>
         <a:xfrm>
           <a:off x="0" y="0"/>
           <a:ext cx="0" cy="0"/>
@@ -1000,7 +941,7 @@
       </p:grpSpPr>
       <p:sp>
         <p:nvSpPr>
-          <p:cNvPr id="1111794236" name="竖排标题 1"/>
+          <p:cNvPr id="2" name="Vertical Title 1"/>
           <p:cNvSpPr>
             <a:spLocks noGrp="1"/>
           </p:cNvSpPr>
@@ -1008,7 +949,7 @@
             <p:ph type="title" orient="vert"/>
           </p:nvPr>
         </p:nvSpPr>
-        <p:spPr bwMode="auto">
+        <p:spPr>
           <a:xfrm>
             <a:off x="8724900" y="365125"/>
             <a:ext cx="2628900" cy="5811838"/>
@@ -1018,19 +959,17 @@
           <a:bodyPr vert="eaVert"/>
           <a:lstStyle/>
           <a:p>
-            <a:pPr>
-              <a:defRPr/>
-            </a:pPr>
-            <a:r>
-              <a:rPr lang="zh-CN"/>
-              <a:t>单击此处编辑母版标题样式</a:t>
-            </a:r>
-          </a:p>
-        </p:txBody>
-      </p:sp>
-      <p:sp>
-        <p:nvSpPr>
-          <p:cNvPr id="2026232647" name="竖排文字占位符 2"/>
+            <a:r>
+              <a:rPr lang="en-US" smtClean="0"/>
+              <a:t>Click to edit Master title style</a:t>
+            </a:r>
+            <a:endParaRPr lang="en-US" dirty="0"/>
+          </a:p>
+        </p:txBody>
+      </p:sp>
+      <p:sp>
+        <p:nvSpPr>
+          <p:cNvPr id="3" name="Vertical Text Placeholder 2"/>
           <p:cNvSpPr>
             <a:spLocks noGrp="1"/>
           </p:cNvSpPr>
@@ -1038,7 +977,7 @@
             <p:ph type="body" orient="vert" idx="1"/>
           </p:nvPr>
         </p:nvSpPr>
-        <p:spPr bwMode="auto">
+        <p:spPr>
           <a:xfrm>
             <a:off x="838200" y="365125"/>
             <a:ext cx="7734300" cy="5811838"/>
@@ -1048,59 +987,46 @@
           <a:bodyPr vert="eaVert"/>
           <a:lstStyle/>
           <a:p>
-            <a:pPr lvl="0">
-              <a:defRPr/>
-            </a:pPr>
-            <a:r>
-              <a:rPr lang="zh-CN"/>
-              <a:t>单击此处编辑母版文本样式</a:t>
-            </a:r>
-            <a:endParaRPr/>
-          </a:p>
-          <a:p>
-            <a:pPr lvl="1">
-              <a:defRPr/>
-            </a:pPr>
-            <a:r>
-              <a:rPr lang="zh-CN"/>
-              <a:t>二级</a:t>
-            </a:r>
-            <a:endParaRPr/>
-          </a:p>
-          <a:p>
-            <a:pPr lvl="2">
-              <a:defRPr/>
-            </a:pPr>
-            <a:r>
-              <a:rPr lang="zh-CN"/>
-              <a:t>三级</a:t>
-            </a:r>
-            <a:endParaRPr/>
-          </a:p>
-          <a:p>
-            <a:pPr lvl="3">
-              <a:defRPr/>
-            </a:pPr>
-            <a:r>
-              <a:rPr lang="zh-CN"/>
-              <a:t>四级</a:t>
-            </a:r>
-            <a:endParaRPr/>
-          </a:p>
-          <a:p>
-            <a:pPr lvl="4">
-              <a:defRPr/>
-            </a:pPr>
-            <a:r>
-              <a:rPr lang="zh-CN"/>
-              <a:t>五级</a:t>
-            </a:r>
-          </a:p>
-        </p:txBody>
-      </p:sp>
-      <p:sp>
-        <p:nvSpPr>
-          <p:cNvPr id="402725679" name="日期占位符 3"/>
+            <a:pPr lvl="0"/>
+            <a:r>
+              <a:rPr lang="en-US" smtClean="0"/>
+              <a:t>Click to edit Master text styles</a:t>
+            </a:r>
+          </a:p>
+          <a:p>
+            <a:pPr lvl="1"/>
+            <a:r>
+              <a:rPr lang="en-US" smtClean="0"/>
+              <a:t>Second level</a:t>
+            </a:r>
+          </a:p>
+          <a:p>
+            <a:pPr lvl="2"/>
+            <a:r>
+              <a:rPr lang="en-US" smtClean="0"/>
+              <a:t>Third level</a:t>
+            </a:r>
+          </a:p>
+          <a:p>
+            <a:pPr lvl="3"/>
+            <a:r>
+              <a:rPr lang="en-US" smtClean="0"/>
+              <a:t>Fourth level</a:t>
+            </a:r>
+          </a:p>
+          <a:p>
+            <a:pPr lvl="4"/>
+            <a:r>
+              <a:rPr lang="en-US" smtClean="0"/>
+              <a:t>Fifth level</a:t>
+            </a:r>
+            <a:endParaRPr lang="en-US" dirty="0"/>
+          </a:p>
+        </p:txBody>
+      </p:sp>
+      <p:sp>
+        <p:nvSpPr>
+          <p:cNvPr id="4" name="Date Placeholder 3"/>
           <p:cNvSpPr>
             <a:spLocks noGrp="1"/>
           </p:cNvSpPr>
@@ -1108,25 +1034,22 @@
             <p:ph type="dt" sz="half" idx="10"/>
           </p:nvPr>
         </p:nvSpPr>
-        <p:spPr bwMode="auto"/>
-        <p:txBody>
-          <a:bodyPr/>
-          <a:lstStyle/>
-          <a:p>
-            <a:pPr>
-              <a:defRPr/>
-            </a:pPr>
+        <p:spPr/>
+        <p:txBody>
+          <a:bodyPr/>
+          <a:lstStyle/>
+          <a:p>
             <a:fld id="{BCC18F51-09EC-435C-A3BA-64A766E099C0}" type="datetimeFigureOut">
-              <a:rPr lang="en-US" altLang="zh-CN"/>
-              <a:t>2026/4/10</a:t>
+              <a:rPr lang="en-US" smtClean="0"/>
+              <a:t>30.10.2013</a:t>
             </a:fld>
-            <a:endParaRPr lang="zh-CN"/>
-          </a:p>
-        </p:txBody>
-      </p:sp>
-      <p:sp>
-        <p:nvSpPr>
-          <p:cNvPr id="977209078" name="页脚占位符 4"/>
+            <a:endParaRPr lang="en-US"/>
+          </a:p>
+        </p:txBody>
+      </p:sp>
+      <p:sp>
+        <p:nvSpPr>
+          <p:cNvPr id="5" name="Footer Placeholder 4"/>
           <p:cNvSpPr>
             <a:spLocks noGrp="1"/>
           </p:cNvSpPr>
@@ -1134,21 +1057,18 @@
             <p:ph type="ftr" sz="quarter" idx="11"/>
           </p:nvPr>
         </p:nvSpPr>
-        <p:spPr bwMode="auto"/>
-        <p:txBody>
-          <a:bodyPr/>
-          <a:lstStyle/>
-          <a:p>
-            <a:pPr>
-              <a:defRPr/>
-            </a:pPr>
-            <a:endParaRPr lang="zh-CN"/>
-          </a:p>
-        </p:txBody>
-      </p:sp>
-      <p:sp>
-        <p:nvSpPr>
-          <p:cNvPr id="431157410" name="灯片编号占位符 5"/>
+        <p:spPr/>
+        <p:txBody>
+          <a:bodyPr/>
+          <a:lstStyle/>
+          <a:p>
+            <a:endParaRPr lang="en-US"/>
+          </a:p>
+        </p:txBody>
+      </p:sp>
+      <p:sp>
+        <p:nvSpPr>
+          <p:cNvPr id="6" name="Slide Number Placeholder 5"/>
           <p:cNvSpPr>
             <a:spLocks noGrp="1"/>
           </p:cNvSpPr>
@@ -1156,23 +1076,25 @@
             <p:ph type="sldNum" sz="quarter" idx="12"/>
           </p:nvPr>
         </p:nvSpPr>
-        <p:spPr bwMode="auto"/>
-        <p:txBody>
-          <a:bodyPr/>
-          <a:lstStyle/>
-          <a:p>
-            <a:pPr>
-              <a:defRPr/>
-            </a:pPr>
+        <p:spPr/>
+        <p:txBody>
+          <a:bodyPr/>
+          <a:lstStyle/>
+          <a:p>
             <a:fld id="{08395586-F03A-48D1-94DF-16B239DF4FB5}" type="slidenum">
-              <a:rPr lang="zh-CN"/>
+              <a:rPr lang="en-US" smtClean="0"/>
               <a:t>‹#›</a:t>
             </a:fld>
-            <a:endParaRPr lang="zh-CN"/>
+            <a:endParaRPr lang="en-US"/>
           </a:p>
         </p:txBody>
       </p:sp>
     </p:spTree>
+    <p:extLst>
+      <p:ext uri="{BB962C8B-B14F-4D97-AF65-F5344CB8AC3E}">
+        <p14:creationId xmlns:p14="http://schemas.microsoft.com/office/powerpoint/2010/main" val="4161801277"/>
+      </p:ext>
+    </p:extLst>
   </p:cSld>
   <p:clrMapOvr>
     <a:masterClrMapping/>
@@ -1181,15 +1103,15 @@
 </file>
 
 <file path=ppt/slideLayouts/slideLayout2.xml><?xml version="1.0" encoding="utf-8"?>
-<p:sldLayout xmlns:a="http://schemas.openxmlformats.org/drawingml/2006/main" xmlns:r="http://schemas.openxmlformats.org/officeDocument/2006/relationships" xmlns:p="http://schemas.openxmlformats.org/presentationml/2006/main" showMasterPhAnim="0" type="obj" preserve="1" userDrawn="1">
-  <p:cSld name="标题和内容">
+<p:sldLayout xmlns:a="http://schemas.openxmlformats.org/drawingml/2006/main" xmlns:r="http://schemas.openxmlformats.org/officeDocument/2006/relationships" xmlns:p="http://schemas.openxmlformats.org/presentationml/2006/main" type="obj" preserve="1">
+  <p:cSld name="Title and Content">
     <p:spTree>
       <p:nvGrpSpPr>
         <p:cNvPr id="1" name=""/>
         <p:cNvGrpSpPr/>
         <p:nvPr/>
       </p:nvGrpSpPr>
-      <p:grpSpPr bwMode="auto">
+      <p:grpSpPr>
         <a:xfrm>
           <a:off x="0" y="0"/>
           <a:ext cx="0" cy="0"/>
@@ -1199,7 +1121,7 @@
       </p:grpSpPr>
       <p:sp>
         <p:nvSpPr>
-          <p:cNvPr id="421125721" name="标题 1"/>
+          <p:cNvPr id="2" name="Title 1"/>
           <p:cNvSpPr>
             <a:spLocks noGrp="1"/>
           </p:cNvSpPr>
@@ -1207,24 +1129,22 @@
             <p:ph type="title"/>
           </p:nvPr>
         </p:nvSpPr>
-        <p:spPr bwMode="auto"/>
-        <p:txBody>
-          <a:bodyPr/>
-          <a:lstStyle/>
-          <a:p>
-            <a:pPr>
-              <a:defRPr/>
-            </a:pPr>
-            <a:r>
-              <a:rPr lang="zh-CN"/>
-              <a:t>单击此处编辑母版标题样式</a:t>
-            </a:r>
-          </a:p>
-        </p:txBody>
-      </p:sp>
-      <p:sp>
-        <p:nvSpPr>
-          <p:cNvPr id="665012651" name="内容占位符 2"/>
+        <p:spPr/>
+        <p:txBody>
+          <a:bodyPr/>
+          <a:lstStyle/>
+          <a:p>
+            <a:r>
+              <a:rPr lang="en-US" smtClean="0"/>
+              <a:t>Click to edit Master title style</a:t>
+            </a:r>
+            <a:endParaRPr lang="en-US" dirty="0"/>
+          </a:p>
+        </p:txBody>
+      </p:sp>
+      <p:sp>
+        <p:nvSpPr>
+          <p:cNvPr id="3" name="Content Placeholder 2"/>
           <p:cNvSpPr>
             <a:spLocks noGrp="1"/>
           </p:cNvSpPr>
@@ -1232,64 +1152,51 @@
             <p:ph idx="1"/>
           </p:nvPr>
         </p:nvSpPr>
-        <p:spPr bwMode="auto"/>
-        <p:txBody>
-          <a:bodyPr/>
-          <a:lstStyle/>
-          <a:p>
-            <a:pPr lvl="0">
-              <a:defRPr/>
-            </a:pPr>
-            <a:r>
-              <a:rPr lang="zh-CN"/>
-              <a:t>单击此处编辑母版文本样式</a:t>
-            </a:r>
-            <a:endParaRPr/>
-          </a:p>
-          <a:p>
-            <a:pPr lvl="1">
-              <a:defRPr/>
-            </a:pPr>
-            <a:r>
-              <a:rPr lang="zh-CN"/>
-              <a:t>二级</a:t>
-            </a:r>
-            <a:endParaRPr/>
-          </a:p>
-          <a:p>
-            <a:pPr lvl="2">
-              <a:defRPr/>
-            </a:pPr>
-            <a:r>
-              <a:rPr lang="zh-CN"/>
-              <a:t>三级</a:t>
-            </a:r>
-            <a:endParaRPr/>
-          </a:p>
-          <a:p>
-            <a:pPr lvl="3">
-              <a:defRPr/>
-            </a:pPr>
-            <a:r>
-              <a:rPr lang="zh-CN"/>
-              <a:t>四级</a:t>
-            </a:r>
-            <a:endParaRPr/>
-          </a:p>
-          <a:p>
-            <a:pPr lvl="4">
-              <a:defRPr/>
-            </a:pPr>
-            <a:r>
-              <a:rPr lang="zh-CN"/>
-              <a:t>五级</a:t>
-            </a:r>
-          </a:p>
-        </p:txBody>
-      </p:sp>
-      <p:sp>
-        <p:nvSpPr>
-          <p:cNvPr id="123473562" name="日期占位符 3"/>
+        <p:spPr/>
+        <p:txBody>
+          <a:bodyPr/>
+          <a:lstStyle/>
+          <a:p>
+            <a:pPr lvl="0"/>
+            <a:r>
+              <a:rPr lang="en-US" smtClean="0"/>
+              <a:t>Click to edit Master text styles</a:t>
+            </a:r>
+          </a:p>
+          <a:p>
+            <a:pPr lvl="1"/>
+            <a:r>
+              <a:rPr lang="en-US" smtClean="0"/>
+              <a:t>Second level</a:t>
+            </a:r>
+          </a:p>
+          <a:p>
+            <a:pPr lvl="2"/>
+            <a:r>
+              <a:rPr lang="en-US" smtClean="0"/>
+              <a:t>Third level</a:t>
+            </a:r>
+          </a:p>
+          <a:p>
+            <a:pPr lvl="3"/>
+            <a:r>
+              <a:rPr lang="en-US" smtClean="0"/>
+              <a:t>Fourth level</a:t>
+            </a:r>
+          </a:p>
+          <a:p>
+            <a:pPr lvl="4"/>
+            <a:r>
+              <a:rPr lang="en-US" smtClean="0"/>
+              <a:t>Fifth level</a:t>
+            </a:r>
+            <a:endParaRPr lang="en-US" dirty="0"/>
+          </a:p>
+        </p:txBody>
+      </p:sp>
+      <p:sp>
+        <p:nvSpPr>
+          <p:cNvPr id="4" name="Date Placeholder 3"/>
           <p:cNvSpPr>
             <a:spLocks noGrp="1"/>
           </p:cNvSpPr>
@@ -1297,25 +1204,22 @@
             <p:ph type="dt" sz="half" idx="10"/>
           </p:nvPr>
         </p:nvSpPr>
-        <p:spPr bwMode="auto"/>
-        <p:txBody>
-          <a:bodyPr/>
-          <a:lstStyle/>
-          <a:p>
-            <a:pPr>
-              <a:defRPr/>
-            </a:pPr>
+        <p:spPr/>
+        <p:txBody>
+          <a:bodyPr/>
+          <a:lstStyle/>
+          <a:p>
             <a:fld id="{BCC18F51-09EC-435C-A3BA-64A766E099C0}" type="datetimeFigureOut">
-              <a:rPr lang="en-US" altLang="zh-CN"/>
-              <a:t>2026/4/10</a:t>
+              <a:rPr lang="en-US" smtClean="0"/>
+              <a:t>30.10.2013</a:t>
             </a:fld>
-            <a:endParaRPr lang="zh-CN"/>
-          </a:p>
-        </p:txBody>
-      </p:sp>
-      <p:sp>
-        <p:nvSpPr>
-          <p:cNvPr id="207730871" name="页脚占位符 4"/>
+            <a:endParaRPr lang="en-US"/>
+          </a:p>
+        </p:txBody>
+      </p:sp>
+      <p:sp>
+        <p:nvSpPr>
+          <p:cNvPr id="5" name="Footer Placeholder 4"/>
           <p:cNvSpPr>
             <a:spLocks noGrp="1"/>
           </p:cNvSpPr>
@@ -1323,21 +1227,18 @@
             <p:ph type="ftr" sz="quarter" idx="11"/>
           </p:nvPr>
         </p:nvSpPr>
-        <p:spPr bwMode="auto"/>
-        <p:txBody>
-          <a:bodyPr/>
-          <a:lstStyle/>
-          <a:p>
-            <a:pPr>
-              <a:defRPr/>
-            </a:pPr>
-            <a:endParaRPr lang="zh-CN"/>
-          </a:p>
-        </p:txBody>
-      </p:sp>
-      <p:sp>
-        <p:nvSpPr>
-          <p:cNvPr id="1513176787" name="灯片编号占位符 5"/>
+        <p:spPr/>
+        <p:txBody>
+          <a:bodyPr/>
+          <a:lstStyle/>
+          <a:p>
+            <a:endParaRPr lang="en-US"/>
+          </a:p>
+        </p:txBody>
+      </p:sp>
+      <p:sp>
+        <p:nvSpPr>
+          <p:cNvPr id="6" name="Slide Number Placeholder 5"/>
           <p:cNvSpPr>
             <a:spLocks noGrp="1"/>
           </p:cNvSpPr>
@@ -1345,23 +1246,25 @@
             <p:ph type="sldNum" sz="quarter" idx="12"/>
           </p:nvPr>
         </p:nvSpPr>
-        <p:spPr bwMode="auto"/>
-        <p:txBody>
-          <a:bodyPr/>
-          <a:lstStyle/>
-          <a:p>
-            <a:pPr>
-              <a:defRPr/>
-            </a:pPr>
+        <p:spPr/>
+        <p:txBody>
+          <a:bodyPr/>
+          <a:lstStyle/>
+          <a:p>
             <a:fld id="{08395586-F03A-48D1-94DF-16B239DF4FB5}" type="slidenum">
-              <a:rPr lang="zh-CN"/>
+              <a:rPr lang="en-US" smtClean="0"/>
               <a:t>‹#›</a:t>
             </a:fld>
-            <a:endParaRPr lang="zh-CN"/>
+            <a:endParaRPr lang="en-US"/>
           </a:p>
         </p:txBody>
       </p:sp>
     </p:spTree>
+    <p:extLst>
+      <p:ext uri="{BB962C8B-B14F-4D97-AF65-F5344CB8AC3E}">
+        <p14:creationId xmlns:p14="http://schemas.microsoft.com/office/powerpoint/2010/main" val="2960619921"/>
+      </p:ext>
+    </p:extLst>
   </p:cSld>
   <p:clrMapOvr>
     <a:masterClrMapping/>
@@ -1370,15 +1273,15 @@
 </file>
 
 <file path=ppt/slideLayouts/slideLayout3.xml><?xml version="1.0" encoding="utf-8"?>
-<p:sldLayout xmlns:a="http://schemas.openxmlformats.org/drawingml/2006/main" xmlns:r="http://schemas.openxmlformats.org/officeDocument/2006/relationships" xmlns:p="http://schemas.openxmlformats.org/presentationml/2006/main" showMasterPhAnim="0" type="secHead" preserve="1" userDrawn="1">
-  <p:cSld name="节标题">
+<p:sldLayout xmlns:a="http://schemas.openxmlformats.org/drawingml/2006/main" xmlns:r="http://schemas.openxmlformats.org/officeDocument/2006/relationships" xmlns:p="http://schemas.openxmlformats.org/presentationml/2006/main" type="secHead" preserve="1">
+  <p:cSld name="Section Header">
     <p:spTree>
       <p:nvGrpSpPr>
         <p:cNvPr id="1" name=""/>
         <p:cNvGrpSpPr/>
         <p:nvPr/>
       </p:nvGrpSpPr>
-      <p:grpSpPr bwMode="auto">
+      <p:grpSpPr>
         <a:xfrm>
           <a:off x="0" y="0"/>
           <a:ext cx="0" cy="0"/>
@@ -1388,7 +1291,7 @@
       </p:grpSpPr>
       <p:sp>
         <p:nvSpPr>
-          <p:cNvPr id="542182457" name="标题 1"/>
+          <p:cNvPr id="2" name="Title 1"/>
           <p:cNvSpPr>
             <a:spLocks noGrp="1"/>
           </p:cNvSpPr>
@@ -1396,7 +1299,7 @@
             <p:ph type="title"/>
           </p:nvPr>
         </p:nvSpPr>
-        <p:spPr bwMode="auto">
+        <p:spPr>
           <a:xfrm>
             <a:off x="831850" y="1709738"/>
             <a:ext cx="10515600" cy="2852737"/>
@@ -1410,19 +1313,17 @@
             </a:lvl1pPr>
           </a:lstStyle>
           <a:p>
-            <a:pPr>
-              <a:defRPr/>
-            </a:pPr>
-            <a:r>
-              <a:rPr lang="zh-CN"/>
-              <a:t>单击此处编辑母版标题样式</a:t>
-            </a:r>
-          </a:p>
-        </p:txBody>
-      </p:sp>
-      <p:sp>
-        <p:nvSpPr>
-          <p:cNvPr id="1830510895" name="文本占位符 2"/>
+            <a:r>
+              <a:rPr lang="en-US" smtClean="0"/>
+              <a:t>Click to edit Master title style</a:t>
+            </a:r>
+            <a:endParaRPr lang="en-US" dirty="0"/>
+          </a:p>
+        </p:txBody>
+      </p:sp>
+      <p:sp>
+        <p:nvSpPr>
+          <p:cNvPr id="3" name="Text Placeholder 2"/>
           <p:cNvSpPr>
             <a:spLocks noGrp="1"/>
           </p:cNvSpPr>
@@ -1430,7 +1331,7 @@
             <p:ph type="body" idx="1"/>
           </p:nvPr>
         </p:nvSpPr>
-        <p:spPr bwMode="auto">
+        <p:spPr>
           <a:xfrm>
             <a:off x="831850" y="4589463"/>
             <a:ext cx="10515600" cy="1500187"/>
@@ -1531,20 +1432,17 @@
             </a:lvl9pPr>
           </a:lstStyle>
           <a:p>
-            <a:pPr lvl="0">
-              <a:defRPr/>
-            </a:pPr>
-            <a:r>
-              <a:rPr lang="zh-CN"/>
-              <a:t>单击此处编辑母版文本样式</a:t>
-            </a:r>
-            <a:endParaRPr/>
-          </a:p>
-        </p:txBody>
-      </p:sp>
-      <p:sp>
-        <p:nvSpPr>
-          <p:cNvPr id="1028891342" name="日期占位符 3"/>
+            <a:pPr lvl="0"/>
+            <a:r>
+              <a:rPr lang="en-US" smtClean="0"/>
+              <a:t>Click to edit Master text styles</a:t>
+            </a:r>
+          </a:p>
+        </p:txBody>
+      </p:sp>
+      <p:sp>
+        <p:nvSpPr>
+          <p:cNvPr id="4" name="Date Placeholder 3"/>
           <p:cNvSpPr>
             <a:spLocks noGrp="1"/>
           </p:cNvSpPr>
@@ -1552,25 +1450,22 @@
             <p:ph type="dt" sz="half" idx="10"/>
           </p:nvPr>
         </p:nvSpPr>
-        <p:spPr bwMode="auto"/>
-        <p:txBody>
-          <a:bodyPr/>
-          <a:lstStyle/>
-          <a:p>
-            <a:pPr>
-              <a:defRPr/>
-            </a:pPr>
+        <p:spPr/>
+        <p:txBody>
+          <a:bodyPr/>
+          <a:lstStyle/>
+          <a:p>
             <a:fld id="{BCC18F51-09EC-435C-A3BA-64A766E099C0}" type="datetimeFigureOut">
-              <a:rPr lang="en-US" altLang="zh-CN"/>
-              <a:t>2026/4/10</a:t>
+              <a:rPr lang="en-US" smtClean="0"/>
+              <a:t>30.10.2013</a:t>
             </a:fld>
-            <a:endParaRPr lang="zh-CN"/>
-          </a:p>
-        </p:txBody>
-      </p:sp>
-      <p:sp>
-        <p:nvSpPr>
-          <p:cNvPr id="83429500" name="页脚占位符 4"/>
+            <a:endParaRPr lang="en-US"/>
+          </a:p>
+        </p:txBody>
+      </p:sp>
+      <p:sp>
+        <p:nvSpPr>
+          <p:cNvPr id="5" name="Footer Placeholder 4"/>
           <p:cNvSpPr>
             <a:spLocks noGrp="1"/>
           </p:cNvSpPr>
@@ -1578,21 +1473,18 @@
             <p:ph type="ftr" sz="quarter" idx="11"/>
           </p:nvPr>
         </p:nvSpPr>
-        <p:spPr bwMode="auto"/>
-        <p:txBody>
-          <a:bodyPr/>
-          <a:lstStyle/>
-          <a:p>
-            <a:pPr>
-              <a:defRPr/>
-            </a:pPr>
-            <a:endParaRPr lang="zh-CN"/>
-          </a:p>
-        </p:txBody>
-      </p:sp>
-      <p:sp>
-        <p:nvSpPr>
-          <p:cNvPr id="281999118" name="Slide Number Placeholder 5"/>
+        <p:spPr/>
+        <p:txBody>
+          <a:bodyPr/>
+          <a:lstStyle/>
+          <a:p>
+            <a:endParaRPr lang="en-US"/>
+          </a:p>
+        </p:txBody>
+      </p:sp>
+      <p:sp>
+        <p:nvSpPr>
+          <p:cNvPr id="6" name="Slide Number Placeholder 5"/>
           <p:cNvSpPr>
             <a:spLocks noGrp="1"/>
           </p:cNvSpPr>
@@ -1600,23 +1492,25 @@
             <p:ph type="sldNum" sz="quarter" idx="12"/>
           </p:nvPr>
         </p:nvSpPr>
-        <p:spPr bwMode="auto"/>
-        <p:txBody>
-          <a:bodyPr/>
-          <a:lstStyle/>
-          <a:p>
-            <a:pPr>
-              <a:defRPr/>
-            </a:pPr>
+        <p:spPr/>
+        <p:txBody>
+          <a:bodyPr/>
+          <a:lstStyle/>
+          <a:p>
             <a:fld id="{08395586-F03A-48D1-94DF-16B239DF4FB5}" type="slidenum">
-              <a:rPr lang="zh-CN"/>
+              <a:rPr lang="en-US" smtClean="0"/>
               <a:t>‹#›</a:t>
             </a:fld>
-            <a:endParaRPr lang="zh-CN"/>
+            <a:endParaRPr lang="en-US"/>
           </a:p>
         </p:txBody>
       </p:sp>
     </p:spTree>
+    <p:extLst>
+      <p:ext uri="{BB962C8B-B14F-4D97-AF65-F5344CB8AC3E}">
+        <p14:creationId xmlns:p14="http://schemas.microsoft.com/office/powerpoint/2010/main" val="2072125890"/>
+      </p:ext>
+    </p:extLst>
   </p:cSld>
   <p:clrMapOvr>
     <a:masterClrMapping/>
@@ -1625,15 +1519,15 @@
 </file>
 
 <file path=ppt/slideLayouts/slideLayout4.xml><?xml version="1.0" encoding="utf-8"?>
-<p:sldLayout xmlns:a="http://schemas.openxmlformats.org/drawingml/2006/main" xmlns:r="http://schemas.openxmlformats.org/officeDocument/2006/relationships" xmlns:p="http://schemas.openxmlformats.org/presentationml/2006/main" showMasterPhAnim="0" type="twoObj" preserve="1" userDrawn="1">
-  <p:cSld name="两栏内容">
+<p:sldLayout xmlns:a="http://schemas.openxmlformats.org/drawingml/2006/main" xmlns:r="http://schemas.openxmlformats.org/officeDocument/2006/relationships" xmlns:p="http://schemas.openxmlformats.org/presentationml/2006/main" type="twoObj" preserve="1">
+  <p:cSld name="Two Content">
     <p:spTree>
       <p:nvGrpSpPr>
         <p:cNvPr id="1" name=""/>
         <p:cNvGrpSpPr/>
         <p:nvPr/>
       </p:nvGrpSpPr>
-      <p:grpSpPr bwMode="auto">
+      <p:grpSpPr>
         <a:xfrm>
           <a:off x="0" y="0"/>
           <a:ext cx="0" cy="0"/>
@@ -1643,7 +1537,7 @@
       </p:grpSpPr>
       <p:sp>
         <p:nvSpPr>
-          <p:cNvPr id="1628266987" name="标题 1"/>
+          <p:cNvPr id="2" name="Title 1"/>
           <p:cNvSpPr>
             <a:spLocks noGrp="1"/>
           </p:cNvSpPr>
@@ -1651,24 +1545,22 @@
             <p:ph type="title"/>
           </p:nvPr>
         </p:nvSpPr>
-        <p:spPr bwMode="auto"/>
-        <p:txBody>
-          <a:bodyPr/>
-          <a:lstStyle/>
-          <a:p>
-            <a:pPr>
-              <a:defRPr/>
-            </a:pPr>
-            <a:r>
-              <a:rPr lang="zh-CN"/>
-              <a:t>单击此处编辑母版标题样式</a:t>
-            </a:r>
-          </a:p>
-        </p:txBody>
-      </p:sp>
-      <p:sp>
-        <p:nvSpPr>
-          <p:cNvPr id="1809361996" name="内容占位符 2"/>
+        <p:spPr/>
+        <p:txBody>
+          <a:bodyPr/>
+          <a:lstStyle/>
+          <a:p>
+            <a:r>
+              <a:rPr lang="en-US" smtClean="0"/>
+              <a:t>Click to edit Master title style</a:t>
+            </a:r>
+            <a:endParaRPr lang="en-US" dirty="0"/>
+          </a:p>
+        </p:txBody>
+      </p:sp>
+      <p:sp>
+        <p:nvSpPr>
+          <p:cNvPr id="3" name="Content Placeholder 2"/>
           <p:cNvSpPr>
             <a:spLocks noGrp="1"/>
           </p:cNvSpPr>
@@ -1676,7 +1568,7 @@
             <p:ph sz="half" idx="1"/>
           </p:nvPr>
         </p:nvSpPr>
-        <p:spPr bwMode="auto">
+        <p:spPr>
           <a:xfrm>
             <a:off x="838200" y="1825625"/>
             <a:ext cx="5181600" cy="4351338"/>
@@ -1686,59 +1578,46 @@
           <a:bodyPr/>
           <a:lstStyle/>
           <a:p>
-            <a:pPr lvl="0">
-              <a:defRPr/>
-            </a:pPr>
-            <a:r>
-              <a:rPr lang="zh-CN"/>
-              <a:t>单击此处编辑母版文本样式</a:t>
-            </a:r>
-            <a:endParaRPr/>
-          </a:p>
-          <a:p>
-            <a:pPr lvl="1">
-              <a:defRPr/>
-            </a:pPr>
-            <a:r>
-              <a:rPr lang="zh-CN"/>
-              <a:t>二级</a:t>
-            </a:r>
-            <a:endParaRPr/>
-          </a:p>
-          <a:p>
-            <a:pPr lvl="2">
-              <a:defRPr/>
-            </a:pPr>
-            <a:r>
-              <a:rPr lang="zh-CN"/>
-              <a:t>三级</a:t>
-            </a:r>
-            <a:endParaRPr/>
-          </a:p>
-          <a:p>
-            <a:pPr lvl="3">
-              <a:defRPr/>
-            </a:pPr>
-            <a:r>
-              <a:rPr lang="zh-CN"/>
-              <a:t>四级</a:t>
-            </a:r>
-            <a:endParaRPr/>
-          </a:p>
-          <a:p>
-            <a:pPr lvl="4">
-              <a:defRPr/>
-            </a:pPr>
-            <a:r>
-              <a:rPr lang="zh-CN"/>
-              <a:t>五级</a:t>
-            </a:r>
-          </a:p>
-        </p:txBody>
-      </p:sp>
-      <p:sp>
-        <p:nvSpPr>
-          <p:cNvPr id="90516450" name="内容占位符 3"/>
+            <a:pPr lvl="0"/>
+            <a:r>
+              <a:rPr lang="en-US" smtClean="0"/>
+              <a:t>Click to edit Master text styles</a:t>
+            </a:r>
+          </a:p>
+          <a:p>
+            <a:pPr lvl="1"/>
+            <a:r>
+              <a:rPr lang="en-US" smtClean="0"/>
+              <a:t>Second level</a:t>
+            </a:r>
+          </a:p>
+          <a:p>
+            <a:pPr lvl="2"/>
+            <a:r>
+              <a:rPr lang="en-US" smtClean="0"/>
+              <a:t>Third level</a:t>
+            </a:r>
+          </a:p>
+          <a:p>
+            <a:pPr lvl="3"/>
+            <a:r>
+              <a:rPr lang="en-US" smtClean="0"/>
+              <a:t>Fourth level</a:t>
+            </a:r>
+          </a:p>
+          <a:p>
+            <a:pPr lvl="4"/>
+            <a:r>
+              <a:rPr lang="en-US" smtClean="0"/>
+              <a:t>Fifth level</a:t>
+            </a:r>
+            <a:endParaRPr lang="en-US" dirty="0"/>
+          </a:p>
+        </p:txBody>
+      </p:sp>
+      <p:sp>
+        <p:nvSpPr>
+          <p:cNvPr id="4" name="Content Placeholder 3"/>
           <p:cNvSpPr>
             <a:spLocks noGrp="1"/>
           </p:cNvSpPr>
@@ -1746,7 +1625,7 @@
             <p:ph sz="half" idx="2"/>
           </p:nvPr>
         </p:nvSpPr>
-        <p:spPr bwMode="auto">
+        <p:spPr>
           <a:xfrm>
             <a:off x="6172200" y="1825625"/>
             <a:ext cx="5181600" cy="4351338"/>
@@ -1756,59 +1635,46 @@
           <a:bodyPr/>
           <a:lstStyle/>
           <a:p>
-            <a:pPr lvl="0">
-              <a:defRPr/>
-            </a:pPr>
-            <a:r>
-              <a:rPr lang="zh-CN"/>
-              <a:t>单击此处编辑母版文本样式</a:t>
-            </a:r>
-            <a:endParaRPr/>
-          </a:p>
-          <a:p>
-            <a:pPr lvl="1">
-              <a:defRPr/>
-            </a:pPr>
-            <a:r>
-              <a:rPr lang="zh-CN"/>
-              <a:t>二级</a:t>
-            </a:r>
-            <a:endParaRPr/>
-          </a:p>
-          <a:p>
-            <a:pPr lvl="2">
-              <a:defRPr/>
-            </a:pPr>
-            <a:r>
-              <a:rPr lang="zh-CN"/>
-              <a:t>三级</a:t>
-            </a:r>
-            <a:endParaRPr/>
-          </a:p>
-          <a:p>
-            <a:pPr lvl="3">
-              <a:defRPr/>
-            </a:pPr>
-            <a:r>
-              <a:rPr lang="zh-CN"/>
-              <a:t>四级</a:t>
-            </a:r>
-            <a:endParaRPr/>
-          </a:p>
-          <a:p>
-            <a:pPr lvl="4">
-              <a:defRPr/>
-            </a:pPr>
-            <a:r>
-              <a:rPr lang="zh-CN"/>
-              <a:t>五级</a:t>
-            </a:r>
-          </a:p>
-        </p:txBody>
-      </p:sp>
-      <p:sp>
-        <p:nvSpPr>
-          <p:cNvPr id="236933850" name="日期占位符 4"/>
+            <a:pPr lvl="0"/>
+            <a:r>
+              <a:rPr lang="en-US" smtClean="0"/>
+              <a:t>Click to edit Master text styles</a:t>
+            </a:r>
+          </a:p>
+          <a:p>
+            <a:pPr lvl="1"/>
+            <a:r>
+              <a:rPr lang="en-US" smtClean="0"/>
+              <a:t>Second level</a:t>
+            </a:r>
+          </a:p>
+          <a:p>
+            <a:pPr lvl="2"/>
+            <a:r>
+              <a:rPr lang="en-US" smtClean="0"/>
+              <a:t>Third level</a:t>
+            </a:r>
+          </a:p>
+          <a:p>
+            <a:pPr lvl="3"/>
+            <a:r>
+              <a:rPr lang="en-US" smtClean="0"/>
+              <a:t>Fourth level</a:t>
+            </a:r>
+          </a:p>
+          <a:p>
+            <a:pPr lvl="4"/>
+            <a:r>
+              <a:rPr lang="en-US" smtClean="0"/>
+              <a:t>Fifth level</a:t>
+            </a:r>
+            <a:endParaRPr lang="en-US" dirty="0"/>
+          </a:p>
+        </p:txBody>
+      </p:sp>
+      <p:sp>
+        <p:nvSpPr>
+          <p:cNvPr id="5" name="Date Placeholder 4"/>
           <p:cNvSpPr>
             <a:spLocks noGrp="1"/>
           </p:cNvSpPr>
@@ -1816,25 +1682,22 @@
             <p:ph type="dt" sz="half" idx="10"/>
           </p:nvPr>
         </p:nvSpPr>
-        <p:spPr bwMode="auto"/>
-        <p:txBody>
-          <a:bodyPr/>
-          <a:lstStyle/>
-          <a:p>
-            <a:pPr>
-              <a:defRPr/>
-            </a:pPr>
+        <p:spPr/>
+        <p:txBody>
+          <a:bodyPr/>
+          <a:lstStyle/>
+          <a:p>
             <a:fld id="{BCC18F51-09EC-435C-A3BA-64A766E099C0}" type="datetimeFigureOut">
-              <a:rPr lang="en-US" altLang="zh-CN"/>
-              <a:t>2026/4/10</a:t>
+              <a:rPr lang="en-US" smtClean="0"/>
+              <a:t>30.10.2013</a:t>
             </a:fld>
-            <a:endParaRPr lang="zh-CN"/>
-          </a:p>
-        </p:txBody>
-      </p:sp>
-      <p:sp>
-        <p:nvSpPr>
-          <p:cNvPr id="1739630649" name="页脚占位符 5"/>
+            <a:endParaRPr lang="en-US"/>
+          </a:p>
+        </p:txBody>
+      </p:sp>
+      <p:sp>
+        <p:nvSpPr>
+          <p:cNvPr id="6" name="Footer Placeholder 5"/>
           <p:cNvSpPr>
             <a:spLocks noGrp="1"/>
           </p:cNvSpPr>
@@ -1842,21 +1705,18 @@
             <p:ph type="ftr" sz="quarter" idx="11"/>
           </p:nvPr>
         </p:nvSpPr>
-        <p:spPr bwMode="auto"/>
-        <p:txBody>
-          <a:bodyPr/>
-          <a:lstStyle/>
-          <a:p>
-            <a:pPr>
-              <a:defRPr/>
-            </a:pPr>
-            <a:endParaRPr lang="zh-CN"/>
-          </a:p>
-        </p:txBody>
-      </p:sp>
-      <p:sp>
-        <p:nvSpPr>
-          <p:cNvPr id="1034111686" name="灯片编号占位符 6"/>
+        <p:spPr/>
+        <p:txBody>
+          <a:bodyPr/>
+          <a:lstStyle/>
+          <a:p>
+            <a:endParaRPr lang="en-US"/>
+          </a:p>
+        </p:txBody>
+      </p:sp>
+      <p:sp>
+        <p:nvSpPr>
+          <p:cNvPr id="7" name="Slide Number Placeholder 6"/>
           <p:cNvSpPr>
             <a:spLocks noGrp="1"/>
           </p:cNvSpPr>
@@ -1864,23 +1724,25 @@
             <p:ph type="sldNum" sz="quarter" idx="12"/>
           </p:nvPr>
         </p:nvSpPr>
-        <p:spPr bwMode="auto"/>
-        <p:txBody>
-          <a:bodyPr/>
-          <a:lstStyle/>
-          <a:p>
-            <a:pPr>
-              <a:defRPr/>
-            </a:pPr>
+        <p:spPr/>
+        <p:txBody>
+          <a:bodyPr/>
+          <a:lstStyle/>
+          <a:p>
             <a:fld id="{08395586-F03A-48D1-94DF-16B239DF4FB5}" type="slidenum">
-              <a:rPr lang="zh-CN"/>
+              <a:rPr lang="en-US" smtClean="0"/>
               <a:t>‹#›</a:t>
             </a:fld>
-            <a:endParaRPr lang="zh-CN"/>
+            <a:endParaRPr lang="en-US"/>
           </a:p>
         </p:txBody>
       </p:sp>
     </p:spTree>
+    <p:extLst>
+      <p:ext uri="{BB962C8B-B14F-4D97-AF65-F5344CB8AC3E}">
+        <p14:creationId xmlns:p14="http://schemas.microsoft.com/office/powerpoint/2010/main" val="4243403397"/>
+      </p:ext>
+    </p:extLst>
   </p:cSld>
   <p:clrMapOvr>
     <a:masterClrMapping/>
@@ -1889,15 +1751,15 @@
 </file>
 
 <file path=ppt/slideLayouts/slideLayout5.xml><?xml version="1.0" encoding="utf-8"?>
-<p:sldLayout xmlns:a="http://schemas.openxmlformats.org/drawingml/2006/main" xmlns:r="http://schemas.openxmlformats.org/officeDocument/2006/relationships" xmlns:p="http://schemas.openxmlformats.org/presentationml/2006/main" showMasterPhAnim="0" type="twoTxTwoObj" preserve="1" userDrawn="1">
-  <p:cSld name="比较">
+<p:sldLayout xmlns:a="http://schemas.openxmlformats.org/drawingml/2006/main" xmlns:r="http://schemas.openxmlformats.org/officeDocument/2006/relationships" xmlns:p="http://schemas.openxmlformats.org/presentationml/2006/main" type="twoTxTwoObj" preserve="1">
+  <p:cSld name="Comparison">
     <p:spTree>
       <p:nvGrpSpPr>
         <p:cNvPr id="1" name=""/>
         <p:cNvGrpSpPr/>
         <p:nvPr/>
       </p:nvGrpSpPr>
-      <p:grpSpPr bwMode="auto">
+      <p:grpSpPr>
         <a:xfrm>
           <a:off x="0" y="0"/>
           <a:ext cx="0" cy="0"/>
@@ -1907,7 +1769,7 @@
       </p:grpSpPr>
       <p:sp>
         <p:nvSpPr>
-          <p:cNvPr id="1389875812" name="标题 1"/>
+          <p:cNvPr id="2" name="Title 1"/>
           <p:cNvSpPr>
             <a:spLocks noGrp="1"/>
           </p:cNvSpPr>
@@ -1915,7 +1777,7 @@
             <p:ph type="title"/>
           </p:nvPr>
         </p:nvSpPr>
-        <p:spPr bwMode="auto">
+        <p:spPr>
           <a:xfrm>
             <a:off x="839788" y="365125"/>
             <a:ext cx="10515600" cy="1325563"/>
@@ -1925,19 +1787,17 @@
           <a:bodyPr/>
           <a:lstStyle/>
           <a:p>
-            <a:pPr>
-              <a:defRPr/>
-            </a:pPr>
-            <a:r>
-              <a:rPr lang="zh-CN"/>
-              <a:t>单击此处编辑母版标题样式</a:t>
-            </a:r>
-          </a:p>
-        </p:txBody>
-      </p:sp>
-      <p:sp>
-        <p:nvSpPr>
-          <p:cNvPr id="265161974" name="文本占位符 2"/>
+            <a:r>
+              <a:rPr lang="en-US" smtClean="0"/>
+              <a:t>Click to edit Master title style</a:t>
+            </a:r>
+            <a:endParaRPr lang="en-US" dirty="0"/>
+          </a:p>
+        </p:txBody>
+      </p:sp>
+      <p:sp>
+        <p:nvSpPr>
+          <p:cNvPr id="3" name="Text Placeholder 2"/>
           <p:cNvSpPr>
             <a:spLocks noGrp="1"/>
           </p:cNvSpPr>
@@ -1945,7 +1805,7 @@
             <p:ph type="body" idx="1"/>
           </p:nvPr>
         </p:nvSpPr>
-        <p:spPr bwMode="auto">
+        <p:spPr>
           <a:xfrm>
             <a:off x="839788" y="1681163"/>
             <a:ext cx="5157787" cy="823912"/>
@@ -1992,20 +1852,17 @@
             </a:lvl9pPr>
           </a:lstStyle>
           <a:p>
-            <a:pPr lvl="0">
-              <a:defRPr/>
-            </a:pPr>
-            <a:r>
-              <a:rPr lang="zh-CN"/>
-              <a:t>单击此处编辑母版文本样式</a:t>
-            </a:r>
-            <a:endParaRPr/>
-          </a:p>
-        </p:txBody>
-      </p:sp>
-      <p:sp>
-        <p:nvSpPr>
-          <p:cNvPr id="1854433795" name="内容占位符 3"/>
+            <a:pPr lvl="0"/>
+            <a:r>
+              <a:rPr lang="en-US" smtClean="0"/>
+              <a:t>Click to edit Master text styles</a:t>
+            </a:r>
+          </a:p>
+        </p:txBody>
+      </p:sp>
+      <p:sp>
+        <p:nvSpPr>
+          <p:cNvPr id="4" name="Content Placeholder 3"/>
           <p:cNvSpPr>
             <a:spLocks noGrp="1"/>
           </p:cNvSpPr>
@@ -2013,9 +1870,9 @@
             <p:ph sz="half" idx="2"/>
           </p:nvPr>
         </p:nvSpPr>
-        <p:spPr bwMode="auto">
+        <p:spPr>
           <a:xfrm>
-            <a:off x="839788" y="2505074"/>
+            <a:off x="839788" y="2505075"/>
             <a:ext cx="5157787" cy="3684588"/>
           </a:xfrm>
         </p:spPr>
@@ -2023,59 +1880,46 @@
           <a:bodyPr/>
           <a:lstStyle/>
           <a:p>
-            <a:pPr lvl="0">
-              <a:defRPr/>
-            </a:pPr>
-            <a:r>
-              <a:rPr lang="zh-CN"/>
-              <a:t>单击此处编辑母版文本样式</a:t>
-            </a:r>
-            <a:endParaRPr/>
-          </a:p>
-          <a:p>
-            <a:pPr lvl="1">
-              <a:defRPr/>
-            </a:pPr>
-            <a:r>
-              <a:rPr lang="zh-CN"/>
-              <a:t>二级</a:t>
-            </a:r>
-            <a:endParaRPr/>
-          </a:p>
-          <a:p>
-            <a:pPr lvl="2">
-              <a:defRPr/>
-            </a:pPr>
-            <a:r>
-              <a:rPr lang="zh-CN"/>
-              <a:t>三级</a:t>
-            </a:r>
-            <a:endParaRPr/>
-          </a:p>
-          <a:p>
-            <a:pPr lvl="3">
-              <a:defRPr/>
-            </a:pPr>
-            <a:r>
-              <a:rPr lang="zh-CN"/>
-              <a:t>四级</a:t>
-            </a:r>
-            <a:endParaRPr/>
-          </a:p>
-          <a:p>
-            <a:pPr lvl="4">
-              <a:defRPr/>
-            </a:pPr>
-            <a:r>
-              <a:rPr lang="zh-CN"/>
-              <a:t>五级</a:t>
-            </a:r>
-          </a:p>
-        </p:txBody>
-      </p:sp>
-      <p:sp>
-        <p:nvSpPr>
-          <p:cNvPr id="21414901" name="文本占位符 4"/>
+            <a:pPr lvl="0"/>
+            <a:r>
+              <a:rPr lang="en-US" smtClean="0"/>
+              <a:t>Click to edit Master text styles</a:t>
+            </a:r>
+          </a:p>
+          <a:p>
+            <a:pPr lvl="1"/>
+            <a:r>
+              <a:rPr lang="en-US" smtClean="0"/>
+              <a:t>Second level</a:t>
+            </a:r>
+          </a:p>
+          <a:p>
+            <a:pPr lvl="2"/>
+            <a:r>
+              <a:rPr lang="en-US" smtClean="0"/>
+              <a:t>Third level</a:t>
+            </a:r>
+          </a:p>
+          <a:p>
+            <a:pPr lvl="3"/>
+            <a:r>
+              <a:rPr lang="en-US" smtClean="0"/>
+              <a:t>Fourth level</a:t>
+            </a:r>
+          </a:p>
+          <a:p>
+            <a:pPr lvl="4"/>
+            <a:r>
+              <a:rPr lang="en-US" smtClean="0"/>
+              <a:t>Fifth level</a:t>
+            </a:r>
+            <a:endParaRPr lang="en-US" dirty="0"/>
+          </a:p>
+        </p:txBody>
+      </p:sp>
+      <p:sp>
+        <p:nvSpPr>
+          <p:cNvPr id="5" name="Text Placeholder 4"/>
           <p:cNvSpPr>
             <a:spLocks noGrp="1"/>
           </p:cNvSpPr>
@@ -2083,7 +1927,7 @@
             <p:ph type="body" sz="quarter" idx="3"/>
           </p:nvPr>
         </p:nvSpPr>
-        <p:spPr bwMode="auto">
+        <p:spPr>
           <a:xfrm>
             <a:off x="6172200" y="1681163"/>
             <a:ext cx="5183188" cy="823912"/>
@@ -2130,20 +1974,17 @@
             </a:lvl9pPr>
           </a:lstStyle>
           <a:p>
-            <a:pPr lvl="0">
-              <a:defRPr/>
-            </a:pPr>
-            <a:r>
-              <a:rPr lang="zh-CN"/>
-              <a:t>单击此处编辑母版文本样式</a:t>
-            </a:r>
-            <a:endParaRPr/>
-          </a:p>
-        </p:txBody>
-      </p:sp>
-      <p:sp>
-        <p:nvSpPr>
-          <p:cNvPr id="149585165" name="内容占位符 5"/>
+            <a:pPr lvl="0"/>
+            <a:r>
+              <a:rPr lang="en-US" smtClean="0"/>
+              <a:t>Click to edit Master text styles</a:t>
+            </a:r>
+          </a:p>
+        </p:txBody>
+      </p:sp>
+      <p:sp>
+        <p:nvSpPr>
+          <p:cNvPr id="6" name="Content Placeholder 5"/>
           <p:cNvSpPr>
             <a:spLocks noGrp="1"/>
           </p:cNvSpPr>
@@ -2151,9 +1992,9 @@
             <p:ph sz="quarter" idx="4"/>
           </p:nvPr>
         </p:nvSpPr>
-        <p:spPr bwMode="auto">
+        <p:spPr>
           <a:xfrm>
-            <a:off x="6172200" y="2505074"/>
+            <a:off x="6172200" y="2505075"/>
             <a:ext cx="5183188" cy="3684588"/>
           </a:xfrm>
         </p:spPr>
@@ -2161,59 +2002,46 @@
           <a:bodyPr/>
           <a:lstStyle/>
           <a:p>
-            <a:pPr lvl="0">
-              <a:defRPr/>
-            </a:pPr>
-            <a:r>
-              <a:rPr lang="zh-CN"/>
-              <a:t>单击此处编辑母版文本样式</a:t>
-            </a:r>
-            <a:endParaRPr/>
-          </a:p>
-          <a:p>
-            <a:pPr lvl="1">
-              <a:defRPr/>
-            </a:pPr>
-            <a:r>
-              <a:rPr lang="zh-CN"/>
-              <a:t>二级</a:t>
-            </a:r>
-            <a:endParaRPr/>
-          </a:p>
-          <a:p>
-            <a:pPr lvl="2">
-              <a:defRPr/>
-            </a:pPr>
-            <a:r>
-              <a:rPr lang="zh-CN"/>
-              <a:t>三级</a:t>
-            </a:r>
-            <a:endParaRPr/>
-          </a:p>
-          <a:p>
-            <a:pPr lvl="3">
-              <a:defRPr/>
-            </a:pPr>
-            <a:r>
-              <a:rPr lang="zh-CN"/>
-              <a:t>四级</a:t>
-            </a:r>
-            <a:endParaRPr/>
-          </a:p>
-          <a:p>
-            <a:pPr lvl="4">
-              <a:defRPr/>
-            </a:pPr>
-            <a:r>
-              <a:rPr lang="zh-CN"/>
-              <a:t>五级</a:t>
-            </a:r>
-          </a:p>
-        </p:txBody>
-      </p:sp>
-      <p:sp>
-        <p:nvSpPr>
-          <p:cNvPr id="1746108761" name="日期占位符 6"/>
+            <a:pPr lvl="0"/>
+            <a:r>
+              <a:rPr lang="en-US" smtClean="0"/>
+              <a:t>Click to edit Master text styles</a:t>
+            </a:r>
+          </a:p>
+          <a:p>
+            <a:pPr lvl="1"/>
+            <a:r>
+              <a:rPr lang="en-US" smtClean="0"/>
+              <a:t>Second level</a:t>
+            </a:r>
+          </a:p>
+          <a:p>
+            <a:pPr lvl="2"/>
+            <a:r>
+              <a:rPr lang="en-US" smtClean="0"/>
+              <a:t>Third level</a:t>
+            </a:r>
+          </a:p>
+          <a:p>
+            <a:pPr lvl="3"/>
+            <a:r>
+              <a:rPr lang="en-US" smtClean="0"/>
+              <a:t>Fourth level</a:t>
+            </a:r>
+          </a:p>
+          <a:p>
+            <a:pPr lvl="4"/>
+            <a:r>
+              <a:rPr lang="en-US" smtClean="0"/>
+              <a:t>Fifth level</a:t>
+            </a:r>
+            <a:endParaRPr lang="en-US" dirty="0"/>
+          </a:p>
+        </p:txBody>
+      </p:sp>
+      <p:sp>
+        <p:nvSpPr>
+          <p:cNvPr id="7" name="Date Placeholder 6"/>
           <p:cNvSpPr>
             <a:spLocks noGrp="1"/>
           </p:cNvSpPr>
@@ -2221,25 +2049,22 @@
             <p:ph type="dt" sz="half" idx="10"/>
           </p:nvPr>
         </p:nvSpPr>
-        <p:spPr bwMode="auto"/>
-        <p:txBody>
-          <a:bodyPr/>
-          <a:lstStyle/>
-          <a:p>
-            <a:pPr>
-              <a:defRPr/>
-            </a:pPr>
+        <p:spPr/>
+        <p:txBody>
+          <a:bodyPr/>
+          <a:lstStyle/>
+          <a:p>
             <a:fld id="{BCC18F51-09EC-435C-A3BA-64A766E099C0}" type="datetimeFigureOut">
-              <a:rPr lang="en-US" altLang="zh-CN"/>
-              <a:t>2026/4/10</a:t>
+              <a:rPr lang="en-US" smtClean="0"/>
+              <a:t>30.10.2013</a:t>
             </a:fld>
-            <a:endParaRPr lang="zh-CN"/>
-          </a:p>
-        </p:txBody>
-      </p:sp>
-      <p:sp>
-        <p:nvSpPr>
-          <p:cNvPr id="2047543986" name="页脚占位符 7"/>
+            <a:endParaRPr lang="en-US"/>
+          </a:p>
+        </p:txBody>
+      </p:sp>
+      <p:sp>
+        <p:nvSpPr>
+          <p:cNvPr id="8" name="Footer Placeholder 7"/>
           <p:cNvSpPr>
             <a:spLocks noGrp="1"/>
           </p:cNvSpPr>
@@ -2247,21 +2072,18 @@
             <p:ph type="ftr" sz="quarter" idx="11"/>
           </p:nvPr>
         </p:nvSpPr>
-        <p:spPr bwMode="auto"/>
-        <p:txBody>
-          <a:bodyPr/>
-          <a:lstStyle/>
-          <a:p>
-            <a:pPr>
-              <a:defRPr/>
-            </a:pPr>
-            <a:endParaRPr lang="zh-CN"/>
-          </a:p>
-        </p:txBody>
-      </p:sp>
-      <p:sp>
-        <p:nvSpPr>
-          <p:cNvPr id="2098727764" name="灯片编号占位符 8"/>
+        <p:spPr/>
+        <p:txBody>
+          <a:bodyPr/>
+          <a:lstStyle/>
+          <a:p>
+            <a:endParaRPr lang="en-US"/>
+          </a:p>
+        </p:txBody>
+      </p:sp>
+      <p:sp>
+        <p:nvSpPr>
+          <p:cNvPr id="9" name="Slide Number Placeholder 8"/>
           <p:cNvSpPr>
             <a:spLocks noGrp="1"/>
           </p:cNvSpPr>
@@ -2269,23 +2091,25 @@
             <p:ph type="sldNum" sz="quarter" idx="12"/>
           </p:nvPr>
         </p:nvSpPr>
-        <p:spPr bwMode="auto"/>
-        <p:txBody>
-          <a:bodyPr/>
-          <a:lstStyle/>
-          <a:p>
-            <a:pPr>
-              <a:defRPr/>
-            </a:pPr>
+        <p:spPr/>
+        <p:txBody>
+          <a:bodyPr/>
+          <a:lstStyle/>
+          <a:p>
             <a:fld id="{08395586-F03A-48D1-94DF-16B239DF4FB5}" type="slidenum">
-              <a:rPr lang="zh-CN"/>
+              <a:rPr lang="en-US" smtClean="0"/>
               <a:t>‹#›</a:t>
             </a:fld>
-            <a:endParaRPr lang="zh-CN"/>
+            <a:endParaRPr lang="en-US"/>
           </a:p>
         </p:txBody>
       </p:sp>
     </p:spTree>
+    <p:extLst>
+      <p:ext uri="{BB962C8B-B14F-4D97-AF65-F5344CB8AC3E}">
+        <p14:creationId xmlns:p14="http://schemas.microsoft.com/office/powerpoint/2010/main" val="3953759558"/>
+      </p:ext>
+    </p:extLst>
   </p:cSld>
   <p:clrMapOvr>
     <a:masterClrMapping/>
@@ -2294,15 +2118,15 @@
 </file>
 
 <file path=ppt/slideLayouts/slideLayout6.xml><?xml version="1.0" encoding="utf-8"?>
-<p:sldLayout xmlns:a="http://schemas.openxmlformats.org/drawingml/2006/main" xmlns:r="http://schemas.openxmlformats.org/officeDocument/2006/relationships" xmlns:p="http://schemas.openxmlformats.org/presentationml/2006/main" showMasterPhAnim="0" type="titleOnly" preserve="1" userDrawn="1">
-  <p:cSld name="仅标题">
+<p:sldLayout xmlns:a="http://schemas.openxmlformats.org/drawingml/2006/main" xmlns:r="http://schemas.openxmlformats.org/officeDocument/2006/relationships" xmlns:p="http://schemas.openxmlformats.org/presentationml/2006/main" type="titleOnly" preserve="1">
+  <p:cSld name="Title Only">
     <p:spTree>
       <p:nvGrpSpPr>
         <p:cNvPr id="1" name=""/>
         <p:cNvGrpSpPr/>
         <p:nvPr/>
       </p:nvGrpSpPr>
-      <p:grpSpPr bwMode="auto">
+      <p:grpSpPr>
         <a:xfrm>
           <a:off x="0" y="0"/>
           <a:ext cx="0" cy="0"/>
@@ -2312,7 +2136,7 @@
       </p:grpSpPr>
       <p:sp>
         <p:nvSpPr>
-          <p:cNvPr id="897274108" name="标题 1"/>
+          <p:cNvPr id="2" name="Title 1"/>
           <p:cNvSpPr>
             <a:spLocks noGrp="1"/>
           </p:cNvSpPr>
@@ -2320,24 +2144,22 @@
             <p:ph type="title"/>
           </p:nvPr>
         </p:nvSpPr>
-        <p:spPr bwMode="auto"/>
-        <p:txBody>
-          <a:bodyPr/>
-          <a:lstStyle/>
-          <a:p>
-            <a:pPr>
-              <a:defRPr/>
-            </a:pPr>
-            <a:r>
-              <a:rPr lang="zh-CN"/>
-              <a:t>单击此处编辑母版标题样式</a:t>
-            </a:r>
-          </a:p>
-        </p:txBody>
-      </p:sp>
-      <p:sp>
-        <p:nvSpPr>
-          <p:cNvPr id="1536027858" name="日期占位符 2"/>
+        <p:spPr/>
+        <p:txBody>
+          <a:bodyPr/>
+          <a:lstStyle/>
+          <a:p>
+            <a:r>
+              <a:rPr lang="en-US" smtClean="0"/>
+              <a:t>Click to edit Master title style</a:t>
+            </a:r>
+            <a:endParaRPr lang="en-US" dirty="0"/>
+          </a:p>
+        </p:txBody>
+      </p:sp>
+      <p:sp>
+        <p:nvSpPr>
+          <p:cNvPr id="3" name="Date Placeholder 2"/>
           <p:cNvSpPr>
             <a:spLocks noGrp="1"/>
           </p:cNvSpPr>
@@ -2345,25 +2167,22 @@
             <p:ph type="dt" sz="half" idx="10"/>
           </p:nvPr>
         </p:nvSpPr>
-        <p:spPr bwMode="auto"/>
-        <p:txBody>
-          <a:bodyPr/>
-          <a:lstStyle/>
-          <a:p>
-            <a:pPr>
-              <a:defRPr/>
-            </a:pPr>
+        <p:spPr/>
+        <p:txBody>
+          <a:bodyPr/>
+          <a:lstStyle/>
+          <a:p>
             <a:fld id="{BCC18F51-09EC-435C-A3BA-64A766E099C0}" type="datetimeFigureOut">
-              <a:rPr lang="en-US" altLang="zh-CN"/>
-              <a:t>2026/4/10</a:t>
+              <a:rPr lang="en-US" smtClean="0"/>
+              <a:t>30.10.2013</a:t>
             </a:fld>
-            <a:endParaRPr lang="zh-CN"/>
-          </a:p>
-        </p:txBody>
-      </p:sp>
-      <p:sp>
-        <p:nvSpPr>
-          <p:cNvPr id="718693365" name="页脚占位符 3"/>
+            <a:endParaRPr lang="en-US"/>
+          </a:p>
+        </p:txBody>
+      </p:sp>
+      <p:sp>
+        <p:nvSpPr>
+          <p:cNvPr id="4" name="Footer Placeholder 3"/>
           <p:cNvSpPr>
             <a:spLocks noGrp="1"/>
           </p:cNvSpPr>
@@ -2371,21 +2190,18 @@
             <p:ph type="ftr" sz="quarter" idx="11"/>
           </p:nvPr>
         </p:nvSpPr>
-        <p:spPr bwMode="auto"/>
-        <p:txBody>
-          <a:bodyPr/>
-          <a:lstStyle/>
-          <a:p>
-            <a:pPr>
-              <a:defRPr/>
-            </a:pPr>
-            <a:endParaRPr lang="zh-CN"/>
-          </a:p>
-        </p:txBody>
-      </p:sp>
-      <p:sp>
-        <p:nvSpPr>
-          <p:cNvPr id="787523423" name="灯片编号占位符 4"/>
+        <p:spPr/>
+        <p:txBody>
+          <a:bodyPr/>
+          <a:lstStyle/>
+          <a:p>
+            <a:endParaRPr lang="en-US"/>
+          </a:p>
+        </p:txBody>
+      </p:sp>
+      <p:sp>
+        <p:nvSpPr>
+          <p:cNvPr id="5" name="Slide Number Placeholder 4"/>
           <p:cNvSpPr>
             <a:spLocks noGrp="1"/>
           </p:cNvSpPr>
@@ -2393,23 +2209,25 @@
             <p:ph type="sldNum" sz="quarter" idx="12"/>
           </p:nvPr>
         </p:nvSpPr>
-        <p:spPr bwMode="auto"/>
-        <p:txBody>
-          <a:bodyPr/>
-          <a:lstStyle/>
-          <a:p>
-            <a:pPr>
-              <a:defRPr/>
-            </a:pPr>
+        <p:spPr/>
+        <p:txBody>
+          <a:bodyPr/>
+          <a:lstStyle/>
+          <a:p>
             <a:fld id="{08395586-F03A-48D1-94DF-16B239DF4FB5}" type="slidenum">
-              <a:rPr lang="zh-CN"/>
+              <a:rPr lang="en-US" smtClean="0"/>
               <a:t>‹#›</a:t>
             </a:fld>
-            <a:endParaRPr lang="zh-CN"/>
+            <a:endParaRPr lang="en-US"/>
           </a:p>
         </p:txBody>
       </p:sp>
     </p:spTree>
+    <p:extLst>
+      <p:ext uri="{BB962C8B-B14F-4D97-AF65-F5344CB8AC3E}">
+        <p14:creationId xmlns:p14="http://schemas.microsoft.com/office/powerpoint/2010/main" val="3815284972"/>
+      </p:ext>
+    </p:extLst>
   </p:cSld>
   <p:clrMapOvr>
     <a:masterClrMapping/>
@@ -2418,15 +2236,15 @@
 </file>
 
 <file path=ppt/slideLayouts/slideLayout7.xml><?xml version="1.0" encoding="utf-8"?>
-<p:sldLayout xmlns:a="http://schemas.openxmlformats.org/drawingml/2006/main" xmlns:r="http://schemas.openxmlformats.org/officeDocument/2006/relationships" xmlns:p="http://schemas.openxmlformats.org/presentationml/2006/main" showMasterPhAnim="0" type="blank" preserve="1" userDrawn="1">
-  <p:cSld name="空白">
+<p:sldLayout xmlns:a="http://schemas.openxmlformats.org/drawingml/2006/main" xmlns:r="http://schemas.openxmlformats.org/officeDocument/2006/relationships" xmlns:p="http://schemas.openxmlformats.org/presentationml/2006/main" type="blank" preserve="1">
+  <p:cSld name="Blank">
     <p:spTree>
       <p:nvGrpSpPr>
         <p:cNvPr id="1" name=""/>
         <p:cNvGrpSpPr/>
         <p:nvPr/>
       </p:nvGrpSpPr>
-      <p:grpSpPr bwMode="auto">
+      <p:grpSpPr>
         <a:xfrm>
           <a:off x="0" y="0"/>
           <a:ext cx="0" cy="0"/>
@@ -2436,7 +2254,7 @@
       </p:grpSpPr>
       <p:sp>
         <p:nvSpPr>
-          <p:cNvPr id="993666087" name="日期占位符 1"/>
+          <p:cNvPr id="2" name="Date Placeholder 1"/>
           <p:cNvSpPr>
             <a:spLocks noGrp="1"/>
           </p:cNvSpPr>
@@ -2444,25 +2262,22 @@
             <p:ph type="dt" sz="half" idx="10"/>
           </p:nvPr>
         </p:nvSpPr>
-        <p:spPr bwMode="auto"/>
-        <p:txBody>
-          <a:bodyPr/>
-          <a:lstStyle/>
-          <a:p>
-            <a:pPr>
-              <a:defRPr/>
-            </a:pPr>
+        <p:spPr/>
+        <p:txBody>
+          <a:bodyPr/>
+          <a:lstStyle/>
+          <a:p>
             <a:fld id="{BCC18F51-09EC-435C-A3BA-64A766E099C0}" type="datetimeFigureOut">
-              <a:rPr lang="en-US" altLang="zh-CN"/>
-              <a:t>2026/4/10</a:t>
+              <a:rPr lang="en-US" smtClean="0"/>
+              <a:t>30.10.2013</a:t>
             </a:fld>
-            <a:endParaRPr lang="zh-CN"/>
-          </a:p>
-        </p:txBody>
-      </p:sp>
-      <p:sp>
-        <p:nvSpPr>
-          <p:cNvPr id="579156694" name="页脚占位符 2"/>
+            <a:endParaRPr lang="en-US"/>
+          </a:p>
+        </p:txBody>
+      </p:sp>
+      <p:sp>
+        <p:nvSpPr>
+          <p:cNvPr id="3" name="Footer Placeholder 2"/>
           <p:cNvSpPr>
             <a:spLocks noGrp="1"/>
           </p:cNvSpPr>
@@ -2470,21 +2285,18 @@
             <p:ph type="ftr" sz="quarter" idx="11"/>
           </p:nvPr>
         </p:nvSpPr>
-        <p:spPr bwMode="auto"/>
-        <p:txBody>
-          <a:bodyPr/>
-          <a:lstStyle/>
-          <a:p>
-            <a:pPr>
-              <a:defRPr/>
-            </a:pPr>
-            <a:endParaRPr lang="zh-CN"/>
-          </a:p>
-        </p:txBody>
-      </p:sp>
-      <p:sp>
-        <p:nvSpPr>
-          <p:cNvPr id="1559616132" name="灯片编号占位符 3"/>
+        <p:spPr/>
+        <p:txBody>
+          <a:bodyPr/>
+          <a:lstStyle/>
+          <a:p>
+            <a:endParaRPr lang="en-US"/>
+          </a:p>
+        </p:txBody>
+      </p:sp>
+      <p:sp>
+        <p:nvSpPr>
+          <p:cNvPr id="4" name="Slide Number Placeholder 3"/>
           <p:cNvSpPr>
             <a:spLocks noGrp="1"/>
           </p:cNvSpPr>
@@ -2492,23 +2304,25 @@
             <p:ph type="sldNum" sz="quarter" idx="12"/>
           </p:nvPr>
         </p:nvSpPr>
-        <p:spPr bwMode="auto"/>
-        <p:txBody>
-          <a:bodyPr/>
-          <a:lstStyle/>
-          <a:p>
-            <a:pPr>
-              <a:defRPr/>
-            </a:pPr>
+        <p:spPr/>
+        <p:txBody>
+          <a:bodyPr/>
+          <a:lstStyle/>
+          <a:p>
             <a:fld id="{08395586-F03A-48D1-94DF-16B239DF4FB5}" type="slidenum">
-              <a:rPr lang="zh-CN"/>
+              <a:rPr lang="en-US" smtClean="0"/>
               <a:t>‹#›</a:t>
             </a:fld>
-            <a:endParaRPr lang="zh-CN"/>
+            <a:endParaRPr lang="en-US"/>
           </a:p>
         </p:txBody>
       </p:sp>
     </p:spTree>
+    <p:extLst>
+      <p:ext uri="{BB962C8B-B14F-4D97-AF65-F5344CB8AC3E}">
+        <p14:creationId xmlns:p14="http://schemas.microsoft.com/office/powerpoint/2010/main" val="3035599116"/>
+      </p:ext>
+    </p:extLst>
   </p:cSld>
   <p:clrMapOvr>
     <a:masterClrMapping/>
@@ -2517,15 +2331,15 @@
 </file>
 
 <file path=ppt/slideLayouts/slideLayout8.xml><?xml version="1.0" encoding="utf-8"?>
-<p:sldLayout xmlns:a="http://schemas.openxmlformats.org/drawingml/2006/main" xmlns:r="http://schemas.openxmlformats.org/officeDocument/2006/relationships" xmlns:p="http://schemas.openxmlformats.org/presentationml/2006/main" showMasterPhAnim="0" type="objTx" preserve="1" userDrawn="1">
-  <p:cSld name="内容与标题">
+<p:sldLayout xmlns:a="http://schemas.openxmlformats.org/drawingml/2006/main" xmlns:r="http://schemas.openxmlformats.org/officeDocument/2006/relationships" xmlns:p="http://schemas.openxmlformats.org/presentationml/2006/main" type="objTx" preserve="1">
+  <p:cSld name="Content with Caption">
     <p:spTree>
       <p:nvGrpSpPr>
         <p:cNvPr id="1" name=""/>
         <p:cNvGrpSpPr/>
         <p:nvPr/>
       </p:nvGrpSpPr>
-      <p:grpSpPr bwMode="auto">
+      <p:grpSpPr>
         <a:xfrm>
           <a:off x="0" y="0"/>
           <a:ext cx="0" cy="0"/>
@@ -2535,7 +2349,7 @@
       </p:grpSpPr>
       <p:sp>
         <p:nvSpPr>
-          <p:cNvPr id="449256111" name="标题 1"/>
+          <p:cNvPr id="2" name="Title 1"/>
           <p:cNvSpPr>
             <a:spLocks noGrp="1"/>
           </p:cNvSpPr>
@@ -2543,7 +2357,7 @@
             <p:ph type="title"/>
           </p:nvPr>
         </p:nvSpPr>
-        <p:spPr bwMode="auto">
+        <p:spPr>
           <a:xfrm>
             <a:off x="839788" y="457200"/>
             <a:ext cx="3932237" cy="1600200"/>
@@ -2557,19 +2371,17 @@
             </a:lvl1pPr>
           </a:lstStyle>
           <a:p>
-            <a:pPr>
-              <a:defRPr/>
-            </a:pPr>
-            <a:r>
-              <a:rPr lang="zh-CN"/>
-              <a:t>单击此处编辑母版标题样式</a:t>
-            </a:r>
-          </a:p>
-        </p:txBody>
-      </p:sp>
-      <p:sp>
-        <p:nvSpPr>
-          <p:cNvPr id="1892078191" name="内容占位符 2"/>
+            <a:r>
+              <a:rPr lang="en-US" smtClean="0"/>
+              <a:t>Click to edit Master title style</a:t>
+            </a:r>
+            <a:endParaRPr lang="en-US" dirty="0"/>
+          </a:p>
+        </p:txBody>
+      </p:sp>
+      <p:sp>
+        <p:nvSpPr>
+          <p:cNvPr id="3" name="Content Placeholder 2"/>
           <p:cNvSpPr>
             <a:spLocks noGrp="1"/>
           </p:cNvSpPr>
@@ -2577,7 +2389,7 @@
             <p:ph idx="1"/>
           </p:nvPr>
         </p:nvSpPr>
-        <p:spPr bwMode="auto">
+        <p:spPr>
           <a:xfrm>
             <a:off x="5183188" y="987425"/>
             <a:ext cx="6172200" cy="4873625"/>
@@ -2615,59 +2427,46 @@
             </a:lvl9pPr>
           </a:lstStyle>
           <a:p>
-            <a:pPr lvl="0">
-              <a:defRPr/>
-            </a:pPr>
-            <a:r>
-              <a:rPr lang="zh-CN"/>
-              <a:t>单击此处编辑母版文本样式</a:t>
-            </a:r>
-            <a:endParaRPr/>
-          </a:p>
-          <a:p>
-            <a:pPr lvl="1">
-              <a:defRPr/>
-            </a:pPr>
-            <a:r>
-              <a:rPr lang="zh-CN"/>
-              <a:t>二级</a:t>
-            </a:r>
-            <a:endParaRPr/>
-          </a:p>
-          <a:p>
-            <a:pPr lvl="2">
-              <a:defRPr/>
-            </a:pPr>
-            <a:r>
-              <a:rPr lang="zh-CN"/>
-              <a:t>三级</a:t>
-            </a:r>
-            <a:endParaRPr/>
-          </a:p>
-          <a:p>
-            <a:pPr lvl="3">
-              <a:defRPr/>
-            </a:pPr>
-            <a:r>
-              <a:rPr lang="zh-CN"/>
-              <a:t>四级</a:t>
-            </a:r>
-            <a:endParaRPr/>
-          </a:p>
-          <a:p>
-            <a:pPr lvl="4">
-              <a:defRPr/>
-            </a:pPr>
-            <a:r>
-              <a:rPr lang="zh-CN"/>
-              <a:t>五级</a:t>
-            </a:r>
-          </a:p>
-        </p:txBody>
-      </p:sp>
-      <p:sp>
-        <p:nvSpPr>
-          <p:cNvPr id="473690543" name="文本占位符 3"/>
+            <a:pPr lvl="0"/>
+            <a:r>
+              <a:rPr lang="en-US" smtClean="0"/>
+              <a:t>Click to edit Master text styles</a:t>
+            </a:r>
+          </a:p>
+          <a:p>
+            <a:pPr lvl="1"/>
+            <a:r>
+              <a:rPr lang="en-US" smtClean="0"/>
+              <a:t>Second level</a:t>
+            </a:r>
+          </a:p>
+          <a:p>
+            <a:pPr lvl="2"/>
+            <a:r>
+              <a:rPr lang="en-US" smtClean="0"/>
+              <a:t>Third level</a:t>
+            </a:r>
+          </a:p>
+          <a:p>
+            <a:pPr lvl="3"/>
+            <a:r>
+              <a:rPr lang="en-US" smtClean="0"/>
+              <a:t>Fourth level</a:t>
+            </a:r>
+          </a:p>
+          <a:p>
+            <a:pPr lvl="4"/>
+            <a:r>
+              <a:rPr lang="en-US" smtClean="0"/>
+              <a:t>Fifth level</a:t>
+            </a:r>
+            <a:endParaRPr lang="en-US" dirty="0"/>
+          </a:p>
+        </p:txBody>
+      </p:sp>
+      <p:sp>
+        <p:nvSpPr>
+          <p:cNvPr id="4" name="Text Placeholder 3"/>
           <p:cNvSpPr>
             <a:spLocks noGrp="1"/>
           </p:cNvSpPr>
@@ -2675,7 +2474,7 @@
             <p:ph type="body" sz="half" idx="2"/>
           </p:nvPr>
         </p:nvSpPr>
-        <p:spPr bwMode="auto">
+        <p:spPr>
           <a:xfrm>
             <a:off x="839788" y="2057400"/>
             <a:ext cx="3932237" cy="3811588"/>
@@ -2722,20 +2521,17 @@
             </a:lvl9pPr>
           </a:lstStyle>
           <a:p>
-            <a:pPr lvl="0">
-              <a:defRPr/>
-            </a:pPr>
-            <a:r>
-              <a:rPr lang="zh-CN"/>
-              <a:t>单击此处编辑母版文本样式</a:t>
-            </a:r>
-            <a:endParaRPr/>
-          </a:p>
-        </p:txBody>
-      </p:sp>
-      <p:sp>
-        <p:nvSpPr>
-          <p:cNvPr id="398524071" name="日期占位符 4"/>
+            <a:pPr lvl="0"/>
+            <a:r>
+              <a:rPr lang="en-US" smtClean="0"/>
+              <a:t>Click to edit Master text styles</a:t>
+            </a:r>
+          </a:p>
+        </p:txBody>
+      </p:sp>
+      <p:sp>
+        <p:nvSpPr>
+          <p:cNvPr id="5" name="Date Placeholder 4"/>
           <p:cNvSpPr>
             <a:spLocks noGrp="1"/>
           </p:cNvSpPr>
@@ -2743,25 +2539,22 @@
             <p:ph type="dt" sz="half" idx="10"/>
           </p:nvPr>
         </p:nvSpPr>
-        <p:spPr bwMode="auto"/>
-        <p:txBody>
-          <a:bodyPr/>
-          <a:lstStyle/>
-          <a:p>
-            <a:pPr>
-              <a:defRPr/>
-            </a:pPr>
+        <p:spPr/>
+        <p:txBody>
+          <a:bodyPr/>
+          <a:lstStyle/>
+          <a:p>
             <a:fld id="{BCC18F51-09EC-435C-A3BA-64A766E099C0}" type="datetimeFigureOut">
-              <a:rPr lang="en-US" altLang="zh-CN"/>
-              <a:t>2026/4/10</a:t>
+              <a:rPr lang="en-US" smtClean="0"/>
+              <a:t>30.10.2013</a:t>
             </a:fld>
-            <a:endParaRPr lang="zh-CN"/>
-          </a:p>
-        </p:txBody>
-      </p:sp>
-      <p:sp>
-        <p:nvSpPr>
-          <p:cNvPr id="702525442" name="页脚占位符 5"/>
+            <a:endParaRPr lang="en-US"/>
+          </a:p>
+        </p:txBody>
+      </p:sp>
+      <p:sp>
+        <p:nvSpPr>
+          <p:cNvPr id="6" name="Footer Placeholder 5"/>
           <p:cNvSpPr>
             <a:spLocks noGrp="1"/>
           </p:cNvSpPr>
@@ -2769,21 +2562,18 @@
             <p:ph type="ftr" sz="quarter" idx="11"/>
           </p:nvPr>
         </p:nvSpPr>
-        <p:spPr bwMode="auto"/>
-        <p:txBody>
-          <a:bodyPr/>
-          <a:lstStyle/>
-          <a:p>
-            <a:pPr>
-              <a:defRPr/>
-            </a:pPr>
-            <a:endParaRPr lang="zh-CN"/>
-          </a:p>
-        </p:txBody>
-      </p:sp>
-      <p:sp>
-        <p:nvSpPr>
-          <p:cNvPr id="1412872458" name="灯片编号占位符 6"/>
+        <p:spPr/>
+        <p:txBody>
+          <a:bodyPr/>
+          <a:lstStyle/>
+          <a:p>
+            <a:endParaRPr lang="en-US"/>
+          </a:p>
+        </p:txBody>
+      </p:sp>
+      <p:sp>
+        <p:nvSpPr>
+          <p:cNvPr id="7" name="Slide Number Placeholder 6"/>
           <p:cNvSpPr>
             <a:spLocks noGrp="1"/>
           </p:cNvSpPr>
@@ -2791,23 +2581,25 @@
             <p:ph type="sldNum" sz="quarter" idx="12"/>
           </p:nvPr>
         </p:nvSpPr>
-        <p:spPr bwMode="auto"/>
-        <p:txBody>
-          <a:bodyPr/>
-          <a:lstStyle/>
-          <a:p>
-            <a:pPr>
-              <a:defRPr/>
-            </a:pPr>
+        <p:spPr/>
+        <p:txBody>
+          <a:bodyPr/>
+          <a:lstStyle/>
+          <a:p>
             <a:fld id="{08395586-F03A-48D1-94DF-16B239DF4FB5}" type="slidenum">
-              <a:rPr lang="zh-CN"/>
+              <a:rPr lang="en-US" smtClean="0"/>
               <a:t>‹#›</a:t>
             </a:fld>
-            <a:endParaRPr lang="zh-CN"/>
+            <a:endParaRPr lang="en-US"/>
           </a:p>
         </p:txBody>
       </p:sp>
     </p:spTree>
+    <p:extLst>
+      <p:ext uri="{BB962C8B-B14F-4D97-AF65-F5344CB8AC3E}">
+        <p14:creationId xmlns:p14="http://schemas.microsoft.com/office/powerpoint/2010/main" val="1714960738"/>
+      </p:ext>
+    </p:extLst>
   </p:cSld>
   <p:clrMapOvr>
     <a:masterClrMapping/>
@@ -2816,15 +2608,15 @@
 </file>
 
 <file path=ppt/slideLayouts/slideLayout9.xml><?xml version="1.0" encoding="utf-8"?>
-<p:sldLayout xmlns:a="http://schemas.openxmlformats.org/drawingml/2006/main" xmlns:r="http://schemas.openxmlformats.org/officeDocument/2006/relationships" xmlns:p="http://schemas.openxmlformats.org/presentationml/2006/main" showMasterPhAnim="0" type="picTx" preserve="1" userDrawn="1">
-  <p:cSld name="图片与标题">
+<p:sldLayout xmlns:a="http://schemas.openxmlformats.org/drawingml/2006/main" xmlns:r="http://schemas.openxmlformats.org/officeDocument/2006/relationships" xmlns:p="http://schemas.openxmlformats.org/presentationml/2006/main" type="picTx" preserve="1">
+  <p:cSld name="Picture with Caption">
     <p:spTree>
       <p:nvGrpSpPr>
         <p:cNvPr id="1" name=""/>
         <p:cNvGrpSpPr/>
         <p:nvPr/>
       </p:nvGrpSpPr>
-      <p:grpSpPr bwMode="auto">
+      <p:grpSpPr>
         <a:xfrm>
           <a:off x="0" y="0"/>
           <a:ext cx="0" cy="0"/>
@@ -2834,7 +2626,7 @@
       </p:grpSpPr>
       <p:sp>
         <p:nvSpPr>
-          <p:cNvPr id="62192004" name="标题 1"/>
+          <p:cNvPr id="2" name="Title 1"/>
           <p:cNvSpPr>
             <a:spLocks noGrp="1"/>
           </p:cNvSpPr>
@@ -2842,7 +2634,7 @@
             <p:ph type="title"/>
           </p:nvPr>
         </p:nvSpPr>
-        <p:spPr bwMode="auto">
+        <p:spPr>
           <a:xfrm>
             <a:off x="839788" y="457200"/>
             <a:ext cx="3932237" cy="1600200"/>
@@ -2856,19 +2648,17 @@
             </a:lvl1pPr>
           </a:lstStyle>
           <a:p>
-            <a:pPr>
-              <a:defRPr/>
-            </a:pPr>
-            <a:r>
-              <a:rPr lang="zh-CN"/>
-              <a:t>单击此处编辑母版标题样式</a:t>
-            </a:r>
-          </a:p>
-        </p:txBody>
-      </p:sp>
-      <p:sp>
-        <p:nvSpPr>
-          <p:cNvPr id="1223859761" name="图片占位符 2"/>
+            <a:r>
+              <a:rPr lang="en-US" smtClean="0"/>
+              <a:t>Click to edit Master title style</a:t>
+            </a:r>
+            <a:endParaRPr lang="en-US" dirty="0"/>
+          </a:p>
+        </p:txBody>
+      </p:sp>
+      <p:sp>
+        <p:nvSpPr>
+          <p:cNvPr id="3" name="Picture Placeholder 2"/>
           <p:cNvSpPr>
             <a:spLocks noGrp="1" noChangeAspect="1"/>
           </p:cNvSpPr>
@@ -2876,7 +2666,7 @@
             <p:ph type="pic" idx="1"/>
           </p:nvPr>
         </p:nvSpPr>
-        <p:spPr bwMode="auto">
+        <p:spPr>
           <a:xfrm>
             <a:off x="5183188" y="987425"/>
             <a:ext cx="6172200" cy="4873625"/>
@@ -2923,19 +2713,17 @@
             </a:lvl9pPr>
           </a:lstStyle>
           <a:p>
-            <a:pPr>
-              <a:defRPr/>
-            </a:pPr>
-            <a:r>
-              <a:rPr lang="zh-CN"/>
-              <a:t>點擊圖示以新增圖片</a:t>
-            </a:r>
-          </a:p>
-        </p:txBody>
-      </p:sp>
-      <p:sp>
-        <p:nvSpPr>
-          <p:cNvPr id="1219796352" name="文本占位符 3"/>
+            <a:r>
+              <a:rPr lang="en-US" smtClean="0"/>
+              <a:t>Click icon to add picture</a:t>
+            </a:r>
+            <a:endParaRPr lang="en-US" dirty="0"/>
+          </a:p>
+        </p:txBody>
+      </p:sp>
+      <p:sp>
+        <p:nvSpPr>
+          <p:cNvPr id="4" name="Text Placeholder 3"/>
           <p:cNvSpPr>
             <a:spLocks noGrp="1"/>
           </p:cNvSpPr>
@@ -2943,7 +2731,7 @@
             <p:ph type="body" sz="half" idx="2"/>
           </p:nvPr>
         </p:nvSpPr>
-        <p:spPr bwMode="auto">
+        <p:spPr>
           <a:xfrm>
             <a:off x="839788" y="2057400"/>
             <a:ext cx="3932237" cy="3811588"/>
@@ -2990,20 +2778,17 @@
             </a:lvl9pPr>
           </a:lstStyle>
           <a:p>
-            <a:pPr lvl="0">
-              <a:defRPr/>
-            </a:pPr>
-            <a:r>
-              <a:rPr lang="zh-CN"/>
-              <a:t>单击此处编辑母版文本样式</a:t>
-            </a:r>
-            <a:endParaRPr/>
-          </a:p>
-        </p:txBody>
-      </p:sp>
-      <p:sp>
-        <p:nvSpPr>
-          <p:cNvPr id="1320725460" name="日期占位符 4"/>
+            <a:pPr lvl="0"/>
+            <a:r>
+              <a:rPr lang="en-US" smtClean="0"/>
+              <a:t>Click to edit Master text styles</a:t>
+            </a:r>
+          </a:p>
+        </p:txBody>
+      </p:sp>
+      <p:sp>
+        <p:nvSpPr>
+          <p:cNvPr id="5" name="Date Placeholder 4"/>
           <p:cNvSpPr>
             <a:spLocks noGrp="1"/>
           </p:cNvSpPr>
@@ -3011,25 +2796,22 @@
             <p:ph type="dt" sz="half" idx="10"/>
           </p:nvPr>
         </p:nvSpPr>
-        <p:spPr bwMode="auto"/>
-        <p:txBody>
-          <a:bodyPr/>
-          <a:lstStyle/>
-          <a:p>
-            <a:pPr>
-              <a:defRPr/>
-            </a:pPr>
+        <p:spPr/>
+        <p:txBody>
+          <a:bodyPr/>
+          <a:lstStyle/>
+          <a:p>
             <a:fld id="{BCC18F51-09EC-435C-A3BA-64A766E099C0}" type="datetimeFigureOut">
-              <a:rPr lang="en-US" altLang="zh-CN"/>
-              <a:t>2026/4/10</a:t>
+              <a:rPr lang="en-US" smtClean="0"/>
+              <a:t>30.10.2013</a:t>
             </a:fld>
-            <a:endParaRPr lang="zh-CN"/>
-          </a:p>
-        </p:txBody>
-      </p:sp>
-      <p:sp>
-        <p:nvSpPr>
-          <p:cNvPr id="1211124596" name="页脚占位符 5"/>
+            <a:endParaRPr lang="en-US"/>
+          </a:p>
+        </p:txBody>
+      </p:sp>
+      <p:sp>
+        <p:nvSpPr>
+          <p:cNvPr id="6" name="Footer Placeholder 5"/>
           <p:cNvSpPr>
             <a:spLocks noGrp="1"/>
           </p:cNvSpPr>
@@ -3037,21 +2819,18 @@
             <p:ph type="ftr" sz="quarter" idx="11"/>
           </p:nvPr>
         </p:nvSpPr>
-        <p:spPr bwMode="auto"/>
-        <p:txBody>
-          <a:bodyPr/>
-          <a:lstStyle/>
-          <a:p>
-            <a:pPr>
-              <a:defRPr/>
-            </a:pPr>
-            <a:endParaRPr lang="zh-CN"/>
-          </a:p>
-        </p:txBody>
-      </p:sp>
-      <p:sp>
-        <p:nvSpPr>
-          <p:cNvPr id="1890298523" name="灯片编号占位符 6"/>
+        <p:spPr/>
+        <p:txBody>
+          <a:bodyPr/>
+          <a:lstStyle/>
+          <a:p>
+            <a:endParaRPr lang="en-US"/>
+          </a:p>
+        </p:txBody>
+      </p:sp>
+      <p:sp>
+        <p:nvSpPr>
+          <p:cNvPr id="7" name="Slide Number Placeholder 6"/>
           <p:cNvSpPr>
             <a:spLocks noGrp="1"/>
           </p:cNvSpPr>
@@ -3059,23 +2838,25 @@
             <p:ph type="sldNum" sz="quarter" idx="12"/>
           </p:nvPr>
         </p:nvSpPr>
-        <p:spPr bwMode="auto"/>
-        <p:txBody>
-          <a:bodyPr/>
-          <a:lstStyle/>
-          <a:p>
-            <a:pPr>
-              <a:defRPr/>
-            </a:pPr>
+        <p:spPr/>
+        <p:txBody>
+          <a:bodyPr/>
+          <a:lstStyle/>
+          <a:p>
             <a:fld id="{08395586-F03A-48D1-94DF-16B239DF4FB5}" type="slidenum">
-              <a:rPr lang="zh-CN"/>
+              <a:rPr lang="en-US" smtClean="0"/>
               <a:t>‹#›</a:t>
             </a:fld>
-            <a:endParaRPr lang="zh-CN"/>
+            <a:endParaRPr lang="en-US"/>
           </a:p>
         </p:txBody>
       </p:sp>
     </p:spTree>
+    <p:extLst>
+      <p:ext uri="{BB962C8B-B14F-4D97-AF65-F5344CB8AC3E}">
+        <p14:creationId xmlns:p14="http://schemas.microsoft.com/office/powerpoint/2010/main" val="3255540774"/>
+      </p:ext>
+    </p:extLst>
   </p:cSld>
   <p:clrMapOvr>
     <a:masterClrMapping/>
@@ -3097,7 +2878,7 @@
         <p:cNvGrpSpPr/>
         <p:nvPr/>
       </p:nvGrpSpPr>
-      <p:grpSpPr bwMode="auto">
+      <p:grpSpPr>
         <a:xfrm>
           <a:off x="0" y="0"/>
           <a:ext cx="0" cy="0"/>
@@ -3107,7 +2888,7 @@
       </p:grpSpPr>
       <p:sp>
         <p:nvSpPr>
-          <p:cNvPr id="383200383" name="标题占位符 1"/>
+          <p:cNvPr id="2" name="Title Placeholder 1"/>
           <p:cNvSpPr>
             <a:spLocks noGrp="1"/>
           </p:cNvSpPr>
@@ -3115,7 +2896,7 @@
             <p:ph type="title"/>
           </p:nvPr>
         </p:nvSpPr>
-        <p:spPr bwMode="auto">
+        <p:spPr>
           <a:xfrm>
             <a:off x="838200" y="365125"/>
             <a:ext cx="10515600" cy="1325563"/>
@@ -3130,19 +2911,17 @@
           </a:bodyPr>
           <a:lstStyle/>
           <a:p>
-            <a:pPr>
-              <a:defRPr/>
-            </a:pPr>
-            <a:r>
-              <a:rPr lang="zh-CN"/>
-              <a:t>单击此处编辑母版标题样式</a:t>
-            </a:r>
-          </a:p>
-        </p:txBody>
-      </p:sp>
-      <p:sp>
-        <p:nvSpPr>
-          <p:cNvPr id="102205264" name="文本占位符 2"/>
+            <a:r>
+              <a:rPr lang="en-US" smtClean="0"/>
+              <a:t>Click to edit Master title style</a:t>
+            </a:r>
+            <a:endParaRPr lang="en-US" dirty="0"/>
+          </a:p>
+        </p:txBody>
+      </p:sp>
+      <p:sp>
+        <p:nvSpPr>
+          <p:cNvPr id="3" name="Text Placeholder 2"/>
           <p:cNvSpPr>
             <a:spLocks noGrp="1"/>
           </p:cNvSpPr>
@@ -3150,7 +2929,7 @@
             <p:ph type="body" idx="1"/>
           </p:nvPr>
         </p:nvSpPr>
-        <p:spPr bwMode="auto">
+        <p:spPr>
           <a:xfrm>
             <a:off x="838200" y="1825625"/>
             <a:ext cx="10515600" cy="4351338"/>
@@ -3165,59 +2944,46 @@
           </a:bodyPr>
           <a:lstStyle/>
           <a:p>
-            <a:pPr lvl="0">
-              <a:defRPr/>
-            </a:pPr>
-            <a:r>
-              <a:rPr lang="zh-CN"/>
-              <a:t>单击此处编辑母版文本样式</a:t>
-            </a:r>
-            <a:endParaRPr/>
-          </a:p>
-          <a:p>
-            <a:pPr lvl="1">
-              <a:defRPr/>
-            </a:pPr>
-            <a:r>
-              <a:rPr lang="zh-CN"/>
-              <a:t>二级</a:t>
-            </a:r>
-            <a:endParaRPr/>
-          </a:p>
-          <a:p>
-            <a:pPr lvl="2">
-              <a:defRPr/>
-            </a:pPr>
-            <a:r>
-              <a:rPr lang="zh-CN"/>
-              <a:t>三级</a:t>
-            </a:r>
-            <a:endParaRPr/>
-          </a:p>
-          <a:p>
-            <a:pPr lvl="3">
-              <a:defRPr/>
-            </a:pPr>
-            <a:r>
-              <a:rPr lang="zh-CN"/>
-              <a:t>四级</a:t>
-            </a:r>
-            <a:endParaRPr/>
-          </a:p>
-          <a:p>
-            <a:pPr lvl="4">
-              <a:defRPr/>
-            </a:pPr>
-            <a:r>
-              <a:rPr lang="zh-CN"/>
-              <a:t>五级</a:t>
-            </a:r>
-          </a:p>
-        </p:txBody>
-      </p:sp>
-      <p:sp>
-        <p:nvSpPr>
-          <p:cNvPr id="777740504" name="日期占位符 3"/>
+            <a:pPr lvl="0"/>
+            <a:r>
+              <a:rPr lang="en-US" smtClean="0"/>
+              <a:t>Click to edit Master text styles</a:t>
+            </a:r>
+          </a:p>
+          <a:p>
+            <a:pPr lvl="1"/>
+            <a:r>
+              <a:rPr lang="en-US" smtClean="0"/>
+              <a:t>Second level</a:t>
+            </a:r>
+          </a:p>
+          <a:p>
+            <a:pPr lvl="2"/>
+            <a:r>
+              <a:rPr lang="en-US" smtClean="0"/>
+              <a:t>Third level</a:t>
+            </a:r>
+          </a:p>
+          <a:p>
+            <a:pPr lvl="3"/>
+            <a:r>
+              <a:rPr lang="en-US" smtClean="0"/>
+              <a:t>Fourth level</a:t>
+            </a:r>
+          </a:p>
+          <a:p>
+            <a:pPr lvl="4"/>
+            <a:r>
+              <a:rPr lang="en-US" smtClean="0"/>
+              <a:t>Fifth level</a:t>
+            </a:r>
+            <a:endParaRPr lang="en-US" dirty="0"/>
+          </a:p>
+        </p:txBody>
+      </p:sp>
+      <p:sp>
+        <p:nvSpPr>
+          <p:cNvPr id="4" name="Date Placeholder 3"/>
           <p:cNvSpPr>
             <a:spLocks noGrp="1"/>
           </p:cNvSpPr>
@@ -3225,7 +2991,7 @@
             <p:ph type="dt" sz="half" idx="2"/>
           </p:nvPr>
         </p:nvSpPr>
-        <p:spPr bwMode="auto">
+        <p:spPr>
           <a:xfrm>
             <a:off x="838200" y="6356350"/>
             <a:ext cx="2743200" cy="365125"/>
@@ -3236,22 +3002,29 @@
         </p:spPr>
         <p:txBody>
           <a:bodyPr vert="horz" lIns="91440" tIns="45720" rIns="91440" bIns="45720" rtlCol="0" anchor="ctr"/>
-          <a:lstStyle/>
-          <a:p>
-            <a:pPr>
-              <a:defRPr/>
-            </a:pPr>
+          <a:lstStyle>
+            <a:lvl1pPr algn="l">
+              <a:defRPr sz="1200">
+                <a:solidFill>
+                  <a:schemeClr val="tx1">
+                    <a:tint val="75000"/>
+                  </a:schemeClr>
+                </a:solidFill>
+              </a:defRPr>
+            </a:lvl1pPr>
+          </a:lstStyle>
+          <a:p>
             <a:fld id="{BCC18F51-09EC-435C-A3BA-64A766E099C0}" type="datetimeFigureOut">
-              <a:rPr lang="en-US" altLang="zh-CN"/>
-              <a:t>2026/4/10</a:t>
+              <a:rPr lang="en-US" smtClean="0"/>
+              <a:t>30.10.2013</a:t>
             </a:fld>
-            <a:endParaRPr lang="zh-CN"/>
-          </a:p>
-        </p:txBody>
-      </p:sp>
-      <p:sp>
-        <p:nvSpPr>
-          <p:cNvPr id="278204060" name="页脚占位符 4"/>
+            <a:endParaRPr lang="en-US"/>
+          </a:p>
+        </p:txBody>
+      </p:sp>
+      <p:sp>
+        <p:nvSpPr>
+          <p:cNvPr id="5" name="Footer Placeholder 4"/>
           <p:cNvSpPr>
             <a:spLocks noGrp="1"/>
           </p:cNvSpPr>
@@ -3259,7 +3032,7 @@
             <p:ph type="ftr" sz="quarter" idx="3"/>
           </p:nvPr>
         </p:nvSpPr>
-        <p:spPr bwMode="auto">
+        <p:spPr>
           <a:xfrm>
             <a:off x="4038600" y="6356350"/>
             <a:ext cx="4114800" cy="365125"/>
@@ -3270,18 +3043,25 @@
         </p:spPr>
         <p:txBody>
           <a:bodyPr vert="horz" lIns="91440" tIns="45720" rIns="91440" bIns="45720" rtlCol="0" anchor="ctr"/>
-          <a:lstStyle/>
-          <a:p>
-            <a:pPr>
-              <a:defRPr/>
-            </a:pPr>
-            <a:endParaRPr lang="zh-CN"/>
-          </a:p>
-        </p:txBody>
-      </p:sp>
-      <p:sp>
-        <p:nvSpPr>
-          <p:cNvPr id="349809884" name="灯片编号占位符 5"/>
+          <a:lstStyle>
+            <a:lvl1pPr algn="ctr">
+              <a:defRPr sz="1200">
+                <a:solidFill>
+                  <a:schemeClr val="tx1">
+                    <a:tint val="75000"/>
+                  </a:schemeClr>
+                </a:solidFill>
+              </a:defRPr>
+            </a:lvl1pPr>
+          </a:lstStyle>
+          <a:p>
+            <a:endParaRPr lang="en-US"/>
+          </a:p>
+        </p:txBody>
+      </p:sp>
+      <p:sp>
+        <p:nvSpPr>
+          <p:cNvPr id="6" name="Slide Number Placeholder 5"/>
           <p:cNvSpPr>
             <a:spLocks noGrp="1"/>
           </p:cNvSpPr>
@@ -3289,7 +3069,7 @@
             <p:ph type="sldNum" sz="quarter" idx="4"/>
           </p:nvPr>
         </p:nvSpPr>
-        <p:spPr bwMode="auto">
+        <p:spPr>
           <a:xfrm>
             <a:off x="8610600" y="6356350"/>
             <a:ext cx="2743200" cy="365125"/>
@@ -3300,46 +3080,58 @@
         </p:spPr>
         <p:txBody>
           <a:bodyPr vert="horz" lIns="91440" tIns="45720" rIns="91440" bIns="45720" rtlCol="0" anchor="ctr"/>
-          <a:lstStyle/>
-          <a:p>
-            <a:pPr>
-              <a:defRPr/>
-            </a:pPr>
+          <a:lstStyle>
+            <a:lvl1pPr algn="r">
+              <a:defRPr sz="1200">
+                <a:solidFill>
+                  <a:schemeClr val="tx1">
+                    <a:tint val="75000"/>
+                  </a:schemeClr>
+                </a:solidFill>
+              </a:defRPr>
+            </a:lvl1pPr>
+          </a:lstStyle>
+          <a:p>
             <a:fld id="{08395586-F03A-48D1-94DF-16B239DF4FB5}" type="slidenum">
-              <a:rPr lang="zh-CN"/>
+              <a:rPr lang="en-US" smtClean="0"/>
               <a:t>‹#›</a:t>
             </a:fld>
-            <a:endParaRPr lang="zh-CN"/>
+            <a:endParaRPr lang="en-US"/>
           </a:p>
         </p:txBody>
       </p:sp>
     </p:spTree>
+    <p:extLst>
+      <p:ext uri="{BB962C8B-B14F-4D97-AF65-F5344CB8AC3E}">
+        <p14:creationId xmlns:p14="http://schemas.microsoft.com/office/powerpoint/2010/main" val="4124136512"/>
+      </p:ext>
+    </p:extLst>
   </p:cSld>
   <p:clrMap bg1="lt1" tx1="dk1" bg2="lt2" tx2="dk2" accent1="accent1" accent2="accent2" accent3="accent3" accent4="accent4" accent5="accent5" accent6="accent6" hlink="hlink" folHlink="folHlink"/>
   <p:sldLayoutIdLst>
-    <p:sldLayoutId id="2147483649" r:id="rId1"/>
-    <p:sldLayoutId id="2147483650" r:id="rId2"/>
-    <p:sldLayoutId id="2147483651" r:id="rId3"/>
-    <p:sldLayoutId id="2147483652" r:id="rId4"/>
-    <p:sldLayoutId id="2147483653" r:id="rId5"/>
-    <p:sldLayoutId id="2147483654" r:id="rId6"/>
-    <p:sldLayoutId id="2147483655" r:id="rId7"/>
-    <p:sldLayoutId id="2147483656" r:id="rId8"/>
-    <p:sldLayoutId id="2147483657" r:id="rId9"/>
-    <p:sldLayoutId id="2147483658" r:id="rId10"/>
-    <p:sldLayoutId id="2147483659" r:id="rId11"/>
+    <p:sldLayoutId id="2147483673" r:id="rId1"/>
+    <p:sldLayoutId id="2147483674" r:id="rId2"/>
+    <p:sldLayoutId id="2147483675" r:id="rId3"/>
+    <p:sldLayoutId id="2147483676" r:id="rId4"/>
+    <p:sldLayoutId id="2147483677" r:id="rId5"/>
+    <p:sldLayoutId id="2147483678" r:id="rId6"/>
+    <p:sldLayoutId id="2147483679" r:id="rId7"/>
+    <p:sldLayoutId id="2147483680" r:id="rId8"/>
+    <p:sldLayoutId id="2147483681" r:id="rId9"/>
+    <p:sldLayoutId id="2147483682" r:id="rId10"/>
+    <p:sldLayoutId id="2147483683" r:id="rId11"/>
   </p:sldLayoutIdLst>
   <p:txStyles>
     <p:titleStyle>
-      <a:lvl1pPr algn="l" defTabSz="914400" rtl="0">
+      <a:lvl1pPr algn="l" defTabSz="914400" rtl="0" eaLnBrk="1" latinLnBrk="0" hangingPunct="1">
         <a:lnSpc>
           <a:spcPct val="90000"/>
         </a:lnSpc>
         <a:spcBef>
-          <a:spcPts val="0"/>
+          <a:spcPct val="0"/>
         </a:spcBef>
         <a:buNone/>
-        <a:defRPr sz="4400">
+        <a:defRPr sz="4400" kern="1200">
           <a:solidFill>
             <a:schemeClr val="tx1"/>
           </a:solidFill>
@@ -3350,16 +3142,16 @@
       </a:lvl1pPr>
     </p:titleStyle>
     <p:bodyStyle>
-      <a:lvl1pPr marL="228600" indent="-228600" algn="l" defTabSz="914400" rtl="0">
+      <a:lvl1pPr marL="228600" indent="-228600" algn="l" defTabSz="914400" rtl="0" eaLnBrk="1" latinLnBrk="0" hangingPunct="1">
         <a:lnSpc>
           <a:spcPct val="90000"/>
         </a:lnSpc>
         <a:spcBef>
           <a:spcPts val="1000"/>
         </a:spcBef>
-        <a:buFont typeface="Arial"/>
+        <a:buFont typeface="Arial" panose="020B0604020202020204" pitchFamily="34" charset="0"/>
         <a:buChar char="•"/>
-        <a:defRPr sz="2800">
+        <a:defRPr sz="2800" kern="1200">
           <a:solidFill>
             <a:schemeClr val="tx1"/>
           </a:solidFill>
@@ -3368,16 +3160,16 @@
           <a:cs typeface="+mn-cs"/>
         </a:defRPr>
       </a:lvl1pPr>
-      <a:lvl2pPr marL="685800" indent="-228600" algn="l" defTabSz="914400" rtl="0">
+      <a:lvl2pPr marL="685800" indent="-228600" algn="l" defTabSz="914400" rtl="0" eaLnBrk="1" latinLnBrk="0" hangingPunct="1">
         <a:lnSpc>
           <a:spcPct val="90000"/>
         </a:lnSpc>
         <a:spcBef>
           <a:spcPts val="500"/>
         </a:spcBef>
-        <a:buFont typeface="Arial"/>
+        <a:buFont typeface="Arial" panose="020B0604020202020204" pitchFamily="34" charset="0"/>
         <a:buChar char="•"/>
-        <a:defRPr sz="2400">
+        <a:defRPr sz="2400" kern="1200">
           <a:solidFill>
             <a:schemeClr val="tx1"/>
           </a:solidFill>
@@ -3386,16 +3178,16 @@
           <a:cs typeface="+mn-cs"/>
         </a:defRPr>
       </a:lvl2pPr>
-      <a:lvl3pPr marL="1143000" indent="-228600" algn="l" defTabSz="914400" rtl="0">
+      <a:lvl3pPr marL="1143000" indent="-228600" algn="l" defTabSz="914400" rtl="0" eaLnBrk="1" latinLnBrk="0" hangingPunct="1">
         <a:lnSpc>
           <a:spcPct val="90000"/>
         </a:lnSpc>
         <a:spcBef>
           <a:spcPts val="500"/>
         </a:spcBef>
-        <a:buFont typeface="Arial"/>
+        <a:buFont typeface="Arial" panose="020B0604020202020204" pitchFamily="34" charset="0"/>
         <a:buChar char="•"/>
-        <a:defRPr sz="2000">
+        <a:defRPr sz="2000" kern="1200">
           <a:solidFill>
             <a:schemeClr val="tx1"/>
           </a:solidFill>
@@ -3404,16 +3196,16 @@
           <a:cs typeface="+mn-cs"/>
         </a:defRPr>
       </a:lvl3pPr>
-      <a:lvl4pPr marL="1600200" indent="-228600" algn="l" defTabSz="914400" rtl="0">
+      <a:lvl4pPr marL="1600200" indent="-228600" algn="l" defTabSz="914400" rtl="0" eaLnBrk="1" latinLnBrk="0" hangingPunct="1">
         <a:lnSpc>
           <a:spcPct val="90000"/>
         </a:lnSpc>
         <a:spcBef>
           <a:spcPts val="500"/>
         </a:spcBef>
-        <a:buFont typeface="Arial"/>
+        <a:buFont typeface="Arial" panose="020B0604020202020204" pitchFamily="34" charset="0"/>
         <a:buChar char="•"/>
-        <a:defRPr sz="1800">
+        <a:defRPr sz="1800" kern="1200">
           <a:solidFill>
             <a:schemeClr val="tx1"/>
           </a:solidFill>
@@ -3422,16 +3214,16 @@
           <a:cs typeface="+mn-cs"/>
         </a:defRPr>
       </a:lvl4pPr>
-      <a:lvl5pPr marL="2057400" indent="-228600" algn="l" defTabSz="914400" rtl="0">
+      <a:lvl5pPr marL="2057400" indent="-228600" algn="l" defTabSz="914400" rtl="0" eaLnBrk="1" latinLnBrk="0" hangingPunct="1">
         <a:lnSpc>
           <a:spcPct val="90000"/>
         </a:lnSpc>
         <a:spcBef>
           <a:spcPts val="500"/>
         </a:spcBef>
-        <a:buFont typeface="Arial"/>
+        <a:buFont typeface="Arial" panose="020B0604020202020204" pitchFamily="34" charset="0"/>
         <a:buChar char="•"/>
-        <a:defRPr sz="1800">
+        <a:defRPr sz="1800" kern="1200">
           <a:solidFill>
             <a:schemeClr val="tx1"/>
           </a:solidFill>
@@ -3440,16 +3232,16 @@
           <a:cs typeface="+mn-cs"/>
         </a:defRPr>
       </a:lvl5pPr>
-      <a:lvl6pPr marL="2514600" indent="-228600" algn="l" defTabSz="914400" rtl="0">
+      <a:lvl6pPr marL="2514600" indent="-228600" algn="l" defTabSz="914400" rtl="0" eaLnBrk="1" latinLnBrk="0" hangingPunct="1">
         <a:lnSpc>
           <a:spcPct val="90000"/>
         </a:lnSpc>
         <a:spcBef>
           <a:spcPts val="500"/>
         </a:spcBef>
-        <a:buFont typeface="Arial"/>
+        <a:buFont typeface="Arial" panose="020B0604020202020204" pitchFamily="34" charset="0"/>
         <a:buChar char="•"/>
-        <a:defRPr sz="1800">
+        <a:defRPr sz="1800" kern="1200">
           <a:solidFill>
             <a:schemeClr val="tx1"/>
           </a:solidFill>
@@ -3458,16 +3250,16 @@
           <a:cs typeface="+mn-cs"/>
         </a:defRPr>
       </a:lvl6pPr>
-      <a:lvl7pPr marL="2971800" indent="-228600" algn="l" defTabSz="914400" rtl="0">
+      <a:lvl7pPr marL="2971800" indent="-228600" algn="l" defTabSz="914400" rtl="0" eaLnBrk="1" latinLnBrk="0" hangingPunct="1">
         <a:lnSpc>
           <a:spcPct val="90000"/>
         </a:lnSpc>
         <a:spcBef>
           <a:spcPts val="500"/>
         </a:spcBef>
-        <a:buFont typeface="Arial"/>
+        <a:buFont typeface="Arial" panose="020B0604020202020204" pitchFamily="34" charset="0"/>
         <a:buChar char="•"/>
-        <a:defRPr sz="1800">
+        <a:defRPr sz="1800" kern="1200">
           <a:solidFill>
             <a:schemeClr val="tx1"/>
           </a:solidFill>
@@ -3476,16 +3268,16 @@
           <a:cs typeface="+mn-cs"/>
         </a:defRPr>
       </a:lvl7pPr>
-      <a:lvl8pPr marL="3429000" indent="-228600" algn="l" defTabSz="914400" rtl="0">
+      <a:lvl8pPr marL="3429000" indent="-228600" algn="l" defTabSz="914400" rtl="0" eaLnBrk="1" latinLnBrk="0" hangingPunct="1">
         <a:lnSpc>
           <a:spcPct val="90000"/>
         </a:lnSpc>
         <a:spcBef>
           <a:spcPts val="500"/>
         </a:spcBef>
-        <a:buFont typeface="Arial"/>
+        <a:buFont typeface="Arial" panose="020B0604020202020204" pitchFamily="34" charset="0"/>
         <a:buChar char="•"/>
-        <a:defRPr sz="1800">
+        <a:defRPr sz="1800" kern="1200">
           <a:solidFill>
             <a:schemeClr val="tx1"/>
           </a:solidFill>
@@ -3494,16 +3286,16 @@
           <a:cs typeface="+mn-cs"/>
         </a:defRPr>
       </a:lvl8pPr>
-      <a:lvl9pPr marL="3886200" indent="-228600" algn="l" defTabSz="914400" rtl="0">
+      <a:lvl9pPr marL="3886200" indent="-228600" algn="l" defTabSz="914400" rtl="0" eaLnBrk="1" latinLnBrk="0" hangingPunct="1">
         <a:lnSpc>
           <a:spcPct val="90000"/>
         </a:lnSpc>
         <a:spcBef>
           <a:spcPts val="500"/>
         </a:spcBef>
-        <a:buFont typeface="Arial"/>
+        <a:buFont typeface="Arial" panose="020B0604020202020204" pitchFamily="34" charset="0"/>
         <a:buChar char="•"/>
-        <a:defRPr sz="1800">
+        <a:defRPr sz="1800" kern="1200">
           <a:solidFill>
             <a:schemeClr val="tx1"/>
           </a:solidFill>
@@ -3515,10 +3307,10 @@
     </p:bodyStyle>
     <p:otherStyle>
       <a:defPPr>
-        <a:defRPr lang="zh-CN"/>
+        <a:defRPr lang="en-US"/>
       </a:defPPr>
-      <a:lvl1pPr marL="0" algn="l" defTabSz="914400" rtl="0">
-        <a:defRPr sz="1800">
+      <a:lvl1pPr marL="0" algn="l" defTabSz="914400" rtl="0" eaLnBrk="1" latinLnBrk="0" hangingPunct="1">
+        <a:defRPr sz="1800" kern="1200">
           <a:solidFill>
             <a:schemeClr val="tx1"/>
           </a:solidFill>
@@ -3527,8 +3319,8 @@
           <a:cs typeface="+mn-cs"/>
         </a:defRPr>
       </a:lvl1pPr>
-      <a:lvl2pPr marL="457200" algn="l" defTabSz="914400" rtl="0">
-        <a:defRPr sz="1800">
+      <a:lvl2pPr marL="457200" algn="l" defTabSz="914400" rtl="0" eaLnBrk="1" latinLnBrk="0" hangingPunct="1">
+        <a:defRPr sz="1800" kern="1200">
           <a:solidFill>
             <a:schemeClr val="tx1"/>
           </a:solidFill>
@@ -3537,8 +3329,8 @@
           <a:cs typeface="+mn-cs"/>
         </a:defRPr>
       </a:lvl2pPr>
-      <a:lvl3pPr marL="914400" algn="l" defTabSz="914400" rtl="0">
-        <a:defRPr sz="1800">
+      <a:lvl3pPr marL="914400" algn="l" defTabSz="914400" rtl="0" eaLnBrk="1" latinLnBrk="0" hangingPunct="1">
+        <a:defRPr sz="1800" kern="1200">
           <a:solidFill>
             <a:schemeClr val="tx1"/>
           </a:solidFill>
@@ -3547,8 +3339,8 @@
           <a:cs typeface="+mn-cs"/>
         </a:defRPr>
       </a:lvl3pPr>
-      <a:lvl4pPr marL="1371600" algn="l" defTabSz="914400" rtl="0">
-        <a:defRPr sz="1800">
+      <a:lvl4pPr marL="1371600" algn="l" defTabSz="914400" rtl="0" eaLnBrk="1" latinLnBrk="0" hangingPunct="1">
+        <a:defRPr sz="1800" kern="1200">
           <a:solidFill>
             <a:schemeClr val="tx1"/>
           </a:solidFill>
@@ -3557,8 +3349,8 @@
           <a:cs typeface="+mn-cs"/>
         </a:defRPr>
       </a:lvl4pPr>
-      <a:lvl5pPr marL="1828800" algn="l" defTabSz="914400" rtl="0">
-        <a:defRPr sz="1800">
+      <a:lvl5pPr marL="1828800" algn="l" defTabSz="914400" rtl="0" eaLnBrk="1" latinLnBrk="0" hangingPunct="1">
+        <a:defRPr sz="1800" kern="1200">
           <a:solidFill>
             <a:schemeClr val="tx1"/>
           </a:solidFill>
@@ -3567,8 +3359,8 @@
           <a:cs typeface="+mn-cs"/>
         </a:defRPr>
       </a:lvl5pPr>
-      <a:lvl6pPr marL="2286000" algn="l" defTabSz="914400" rtl="0">
-        <a:defRPr sz="1800">
+      <a:lvl6pPr marL="2286000" algn="l" defTabSz="914400" rtl="0" eaLnBrk="1" latinLnBrk="0" hangingPunct="1">
+        <a:defRPr sz="1800" kern="1200">
           <a:solidFill>
             <a:schemeClr val="tx1"/>
           </a:solidFill>
@@ -3577,8 +3369,8 @@
           <a:cs typeface="+mn-cs"/>
         </a:defRPr>
       </a:lvl6pPr>
-      <a:lvl7pPr marL="2743200" algn="l" defTabSz="914400" rtl="0">
-        <a:defRPr sz="1800">
+      <a:lvl7pPr marL="2743200" algn="l" defTabSz="914400" rtl="0" eaLnBrk="1" latinLnBrk="0" hangingPunct="1">
+        <a:defRPr sz="1800" kern="1200">
           <a:solidFill>
             <a:schemeClr val="tx1"/>
           </a:solidFill>
@@ -3587,8 +3379,8 @@
           <a:cs typeface="+mn-cs"/>
         </a:defRPr>
       </a:lvl7pPr>
-      <a:lvl8pPr marL="3200400" algn="l" defTabSz="914400" rtl="0">
-        <a:defRPr sz="1800">
+      <a:lvl8pPr marL="3200400" algn="l" defTabSz="914400" rtl="0" eaLnBrk="1" latinLnBrk="0" hangingPunct="1">
+        <a:defRPr sz="1800" kern="1200">
           <a:solidFill>
             <a:schemeClr val="tx1"/>
           </a:solidFill>
@@ -3597,8 +3389,8 @@
           <a:cs typeface="+mn-cs"/>
         </a:defRPr>
       </a:lvl8pPr>
-      <a:lvl9pPr marL="3657600" algn="l" defTabSz="914400" rtl="0">
-        <a:defRPr sz="1800">
+      <a:lvl9pPr marL="3657600" algn="l" defTabSz="914400" rtl="0" eaLnBrk="1" latinLnBrk="0" hangingPunct="1">
+        <a:defRPr sz="1800" kern="1200">
           <a:solidFill>
             <a:schemeClr val="tx1"/>
           </a:solidFill>
@@ -3613,7 +3405,7 @@
 </file>
 
 <file path=ppt/slides/slide1.xml><?xml version="1.0" encoding="utf-8"?>
-<p:sld xmlns:a="http://schemas.openxmlformats.org/drawingml/2006/main" xmlns:r="http://schemas.openxmlformats.org/officeDocument/2006/relationships" xmlns:p="http://schemas.openxmlformats.org/presentationml/2006/main" showMasterPhAnim="0">
+<p:sld xmlns:a="http://schemas.openxmlformats.org/drawingml/2006/main" xmlns:r="http://schemas.openxmlformats.org/officeDocument/2006/relationships" xmlns:p="http://schemas.openxmlformats.org/presentationml/2006/main">
   <p:cSld>
     <p:spTree>
       <p:nvGrpSpPr>
@@ -3621,7 +3413,7 @@
         <p:cNvGrpSpPr/>
         <p:nvPr/>
       </p:nvGrpSpPr>
-      <p:grpSpPr bwMode="auto">
+      <p:grpSpPr>
         <a:xfrm>
           <a:off x="0" y="0"/>
           <a:ext cx="0" cy="0"/>
@@ -3631,7 +3423,7 @@
       </p:grpSpPr>
       <p:sp>
         <p:nvSpPr>
-          <p:cNvPr id="1206612760" name="标题 1"/>
+          <p:cNvPr id="2" name="Title 1"/>
           <p:cNvSpPr>
             <a:spLocks noGrp="1"/>
           </p:cNvSpPr>
@@ -3639,18 +3431,18 @@
             <p:ph type="ctrTitle"/>
           </p:nvPr>
         </p:nvSpPr>
-        <p:spPr bwMode="auto"/>
-        <p:txBody>
-          <a:bodyPr/>
-          <a:lstStyle/>
-          <a:p>
-            <a:endParaRPr lang="zh-CN" dirty="0"/>
-          </a:p>
-        </p:txBody>
-      </p:sp>
-      <p:sp>
-        <p:nvSpPr>
-          <p:cNvPr id="37649361" name="副标题 2"/>
+        <p:spPr/>
+        <p:txBody>
+          <a:bodyPr/>
+          <a:lstStyle/>
+          <a:p>
+            <a:endParaRPr lang="en-US" dirty="0"/>
+          </a:p>
+        </p:txBody>
+      </p:sp>
+      <p:sp>
+        <p:nvSpPr>
+          <p:cNvPr id="3" name="Subtitle 2"/>
           <p:cNvSpPr>
             <a:spLocks noGrp="1"/>
           </p:cNvSpPr>
@@ -3658,16 +3450,21 @@
             <p:ph type="subTitle" idx="1"/>
           </p:nvPr>
         </p:nvSpPr>
-        <p:spPr bwMode="auto"/>
-        <p:txBody>
-          <a:bodyPr/>
-          <a:lstStyle/>
-          <a:p>
-            <a:endParaRPr lang="zh-CN" dirty="0"/>
+        <p:spPr/>
+        <p:txBody>
+          <a:bodyPr/>
+          <a:lstStyle/>
+          <a:p>
+            <a:endParaRPr lang="en-US" dirty="0"/>
           </a:p>
         </p:txBody>
       </p:sp>
     </p:spTree>
+    <p:extLst>
+      <p:ext uri="{BB962C8B-B14F-4D97-AF65-F5344CB8AC3E}">
+        <p14:creationId xmlns:p14="http://schemas.microsoft.com/office/powerpoint/2010/main" val="2426011969"/>
+      </p:ext>
+    </p:extLst>
   </p:cSld>
   <p:clrMapOvr>
     <a:masterClrMapping/>
@@ -3718,12 +3515,12 @@
     </a:clrScheme>
     <a:fontScheme name="Office Theme">
       <a:majorFont>
-        <a:latin typeface="等线 Light" panose="020F0302020204030204"/>
+        <a:latin typeface="Arial" panose="020F0302020204030204"/>
         <a:ea typeface=""/>
         <a:cs typeface=""/>
-        <a:font script="Jpan" typeface="游ゴシック Light"/>
+        <a:font script="Jpan" typeface="ＭＳ Ｐゴシック"/>
         <a:font script="Hang" typeface="맑은 고딕"/>
-        <a:font script="Hans" typeface="等线 Light"/>
+        <a:font script="Hans" typeface="宋体"/>
         <a:font script="Hant" typeface="新細明體"/>
         <a:font script="Arab" typeface="Times New Roman"/>
         <a:font script="Hebr" typeface="Times New Roman"/>
@@ -3751,31 +3548,14 @@
         <a:font script="Viet" typeface="Times New Roman"/>
         <a:font script="Uigh" typeface="Microsoft Uighur"/>
         <a:font script="Geor" typeface="Sylfaen"/>
-        <a:font script="Armn" typeface="Arial"/>
-        <a:font script="Bugi" typeface="Leelawadee UI"/>
-        <a:font script="Bopo" typeface="Microsoft JhengHei"/>
-        <a:font script="Java" typeface="Javanese Text"/>
-        <a:font script="Lisu" typeface="Segoe UI"/>
-        <a:font script="Mymr" typeface="Myanmar Text"/>
-        <a:font script="Nkoo" typeface="Ebrima"/>
-        <a:font script="Olck" typeface="Nirmala UI"/>
-        <a:font script="Osma" typeface="Ebrima"/>
-        <a:font script="Phag" typeface="Phagspa"/>
-        <a:font script="Syrn" typeface="Estrangelo Edessa"/>
-        <a:font script="Syrj" typeface="Estrangelo Edessa"/>
-        <a:font script="Syre" typeface="Estrangelo Edessa"/>
-        <a:font script="Sora" typeface="Nirmala UI"/>
-        <a:font script="Tale" typeface="Microsoft Tai Le"/>
-        <a:font script="Talu" typeface="Microsoft New Tai Lue"/>
-        <a:font script="Tfng" typeface="Ebrima"/>
       </a:majorFont>
       <a:minorFont>
-        <a:latin typeface="等线" panose="020F0502020204030204"/>
+        <a:latin typeface="Arial" panose="020F0502020204030204"/>
         <a:ea typeface=""/>
         <a:cs typeface=""/>
-        <a:font script="Jpan" typeface="游ゴシック"/>
+        <a:font script="Jpan" typeface="ＭＳ Ｐゴシック"/>
         <a:font script="Hang" typeface="맑은 고딕"/>
-        <a:font script="Hans" typeface="等线"/>
+        <a:font script="Hans" typeface="宋体"/>
         <a:font script="Hant" typeface="新細明體"/>
         <a:font script="Arab" typeface="Arial"/>
         <a:font script="Hebr" typeface="Arial"/>
@@ -3803,23 +3583,6 @@
         <a:font script="Viet" typeface="Arial"/>
         <a:font script="Uigh" typeface="Microsoft Uighur"/>
         <a:font script="Geor" typeface="Sylfaen"/>
-        <a:font script="Armn" typeface="Arial"/>
-        <a:font script="Bugi" typeface="Leelawadee UI"/>
-        <a:font script="Bopo" typeface="Microsoft JhengHei"/>
-        <a:font script="Java" typeface="Javanese Text"/>
-        <a:font script="Lisu" typeface="Segoe UI"/>
-        <a:font script="Mymr" typeface="Myanmar Text"/>
-        <a:font script="Nkoo" typeface="Ebrima"/>
-        <a:font script="Olck" typeface="Nirmala UI"/>
-        <a:font script="Osma" typeface="Ebrima"/>
-        <a:font script="Phag" typeface="Phagspa"/>
-        <a:font script="Syrn" typeface="Estrangelo Edessa"/>
-        <a:font script="Syrj" typeface="Estrangelo Edessa"/>
-        <a:font script="Syre" typeface="Estrangelo Edessa"/>
-        <a:font script="Sora" typeface="Nirmala UI"/>
-        <a:font script="Tale" typeface="Microsoft Tai Le"/>
-        <a:font script="Talu" typeface="Microsoft New Tai Lue"/>
-        <a:font script="Tfng" typeface="Ebrima"/>
       </a:minorFont>
     </a:fontScheme>
     <a:fmtScheme name="Office Theme">
@@ -3987,7 +3750,7 @@
         <a:srgbClr val="E7E6E6"/>
       </a:lt2>
       <a:accent1>
-        <a:srgbClr val="4472C4"/>
+        <a:srgbClr val="5B9BD5"/>
       </a:accent1>
       <a:accent2>
         <a:srgbClr val="ED7D31"/>
@@ -3999,7 +3762,7 @@
         <a:srgbClr val="FFC000"/>
       </a:accent4>
       <a:accent5>
-        <a:srgbClr val="5B9BD5"/>
+        <a:srgbClr val="4472C4"/>
       </a:accent5>
       <a:accent6>
         <a:srgbClr val="70AD47"/>
@@ -4011,70 +3774,18 @@
         <a:srgbClr val="954F72"/>
       </a:folHlink>
     </a:clrScheme>
-    <a:fontScheme name="Office">
+    <a:fontScheme name="Arial">
       <a:majorFont>
-        <a:latin typeface="Calibri Light" panose="020F0302020204030204"/>
+        <a:latin typeface="Arial" panose="020B0604020202020204"/>
         <a:ea typeface=""/>
         <a:cs typeface=""/>
-        <a:font script="Jpan" typeface="游ゴシック Light"/>
+        <a:font script="Jpan" typeface="ＭＳ ゴシック"/>
         <a:font script="Hang" typeface="맑은 고딕"/>
-        <a:font script="Hans" typeface="等线 Light"/>
+        <a:font script="Hans" typeface="宋体"/>
         <a:font script="Hant" typeface="新細明體"/>
-        <a:font script="Arab" typeface="Times New Roman"/>
-        <a:font script="Hebr" typeface="Times New Roman"/>
-        <a:font script="Thai" typeface="Angsana New"/>
-        <a:font script="Ethi" typeface="Nyala"/>
-        <a:font script="Beng" typeface="Vrinda"/>
-        <a:font script="Gujr" typeface="Shruti"/>
-        <a:font script="Khmr" typeface="MoolBoran"/>
-        <a:font script="Knda" typeface="Tunga"/>
-        <a:font script="Guru" typeface="Raavi"/>
-        <a:font script="Cans" typeface="Euphemia"/>
-        <a:font script="Cher" typeface="Plantagenet Cherokee"/>
-        <a:font script="Yiii" typeface="Microsoft Yi Baiti"/>
-        <a:font script="Tibt" typeface="Microsoft Himalaya"/>
-        <a:font script="Thaa" typeface="MV Boli"/>
-        <a:font script="Deva" typeface="Mangal"/>
-        <a:font script="Telu" typeface="Gautami"/>
-        <a:font script="Taml" typeface="Latha"/>
-        <a:font script="Syrc" typeface="Estrangelo Edessa"/>
-        <a:font script="Orya" typeface="Kalinga"/>
-        <a:font script="Mlym" typeface="Kartika"/>
-        <a:font script="Laoo" typeface="DokChampa"/>
-        <a:font script="Sinh" typeface="Iskoola Pota"/>
-        <a:font script="Mong" typeface="Mongolian Baiti"/>
-        <a:font script="Viet" typeface="Times New Roman"/>
-        <a:font script="Uigh" typeface="Microsoft Uighur"/>
-        <a:font script="Geor" typeface="Sylfaen"/>
-        <a:font script="Armn" typeface="Arial"/>
-        <a:font script="Bugi" typeface="Leelawadee UI"/>
-        <a:font script="Bopo" typeface="Microsoft JhengHei"/>
-        <a:font script="Java" typeface="Javanese Text"/>
-        <a:font script="Lisu" typeface="Segoe UI"/>
-        <a:font script="Mymr" typeface="Myanmar Text"/>
-        <a:font script="Nkoo" typeface="Ebrima"/>
-        <a:font script="Olck" typeface="Nirmala UI"/>
-        <a:font script="Osma" typeface="Ebrima"/>
-        <a:font script="Phag" typeface="Phagspa"/>
-        <a:font script="Syrn" typeface="Estrangelo Edessa"/>
-        <a:font script="Syrj" typeface="Estrangelo Edessa"/>
-        <a:font script="Syre" typeface="Estrangelo Edessa"/>
-        <a:font script="Sora" typeface="Nirmala UI"/>
-        <a:font script="Tale" typeface="Microsoft Tai Le"/>
-        <a:font script="Talu" typeface="Microsoft New Tai Lue"/>
-        <a:font script="Tfng" typeface="Ebrima"/>
-      </a:majorFont>
-      <a:minorFont>
-        <a:latin typeface="Calibri" panose="020F0502020204030204"/>
-        <a:ea typeface=""/>
-        <a:cs typeface=""/>
-        <a:font script="Jpan" typeface="游ゴシック"/>
-        <a:font script="Hang" typeface="맑은 고딕"/>
-        <a:font script="Hans" typeface="等线"/>
-        <a:font script="Hant" typeface="新細明體"/>
-        <a:font script="Arab" typeface="Arial"/>
-        <a:font script="Hebr" typeface="Arial"/>
-        <a:font script="Thai" typeface="Cordia New"/>
+        <a:font script="Arab" typeface="Tahoma"/>
+        <a:font script="Hebr" typeface="Gisha"/>
+        <a:font script="Thai" typeface="DilleniaUPC"/>
         <a:font script="Ethi" typeface="Nyala"/>
         <a:font script="Beng" typeface="Vrinda"/>
         <a:font script="Gujr" typeface="Shruti"/>
@@ -4095,26 +3806,44 @@
         <a:font script="Laoo" typeface="DokChampa"/>
         <a:font script="Sinh" typeface="Iskoola Pota"/>
         <a:font script="Mong" typeface="Mongolian Baiti"/>
-        <a:font script="Viet" typeface="Arial"/>
+        <a:font script="Viet" typeface="Tahoma"/>
         <a:font script="Uigh" typeface="Microsoft Uighur"/>
         <a:font script="Geor" typeface="Sylfaen"/>
-        <a:font script="Armn" typeface="Arial"/>
-        <a:font script="Bugi" typeface="Leelawadee UI"/>
-        <a:font script="Bopo" typeface="Microsoft JhengHei"/>
-        <a:font script="Java" typeface="Javanese Text"/>
-        <a:font script="Lisu" typeface="Segoe UI"/>
-        <a:font script="Mymr" typeface="Myanmar Text"/>
-        <a:font script="Nkoo" typeface="Ebrima"/>
-        <a:font script="Olck" typeface="Nirmala UI"/>
-        <a:font script="Osma" typeface="Ebrima"/>
-        <a:font script="Phag" typeface="Phagspa"/>
-        <a:font script="Syrn" typeface="Estrangelo Edessa"/>
-        <a:font script="Syrj" typeface="Estrangelo Edessa"/>
-        <a:font script="Syre" typeface="Estrangelo Edessa"/>
-        <a:font script="Sora" typeface="Nirmala UI"/>
-        <a:font script="Tale" typeface="Microsoft Tai Le"/>
-        <a:font script="Talu" typeface="Microsoft New Tai Lue"/>
-        <a:font script="Tfng" typeface="Ebrima"/>
+      </a:majorFont>
+      <a:minorFont>
+        <a:latin typeface="Arial" panose="020B0604020202020204"/>
+        <a:ea typeface=""/>
+        <a:cs typeface=""/>
+        <a:font script="Jpan" typeface="ＭＳ ゴシック"/>
+        <a:font script="Hang" typeface="맑은 고딕"/>
+        <a:font script="Hans" typeface="宋体"/>
+        <a:font script="Hant" typeface="新細明體"/>
+        <a:font script="Arab" typeface="Tahoma"/>
+        <a:font script="Hebr" typeface="Gisha"/>
+        <a:font script="Thai" typeface="DilleniaUPC"/>
+        <a:font script="Ethi" typeface="Nyala"/>
+        <a:font script="Beng" typeface="Vrinda"/>
+        <a:font script="Gujr" typeface="Shruti"/>
+        <a:font script="Khmr" typeface="DaunPenh"/>
+        <a:font script="Knda" typeface="Tunga"/>
+        <a:font script="Guru" typeface="Raavi"/>
+        <a:font script="Cans" typeface="Euphemia"/>
+        <a:font script="Cher" typeface="Plantagenet Cherokee"/>
+        <a:font script="Yiii" typeface="Microsoft Yi Baiti"/>
+        <a:font script="Tibt" typeface="Microsoft Himalaya"/>
+        <a:font script="Thaa" typeface="MV Boli"/>
+        <a:font script="Deva" typeface="Mangal"/>
+        <a:font script="Telu" typeface="Gautami"/>
+        <a:font script="Taml" typeface="Latha"/>
+        <a:font script="Syrc" typeface="Estrangelo Edessa"/>
+        <a:font script="Orya" typeface="Kalinga"/>
+        <a:font script="Mlym" typeface="Kartika"/>
+        <a:font script="Laoo" typeface="DokChampa"/>
+        <a:font script="Sinh" typeface="Iskoola Pota"/>
+        <a:font script="Mong" typeface="Mongolian Baiti"/>
+        <a:font script="Viet" typeface="Verdana"/>
+        <a:font script="Uigh" typeface="Microsoft Uighur"/>
+        <a:font script="Geor" typeface="Sylfaen"/>
       </a:minorFont>
     </a:fontScheme>
     <a:fmtScheme name="Office">

</xml_diff>